<commit_message>
edit session 1 and 2
</commit_message>
<xml_diff>
--- a/session_1_intro/slides_1_intro.pptx
+++ b/session_1_intro/slides_1_intro.pptx
@@ -5,7 +5,7 @@
     <p:sldMasterId id="2147483648" r:id="rId1"/>
   </p:sldMasterIdLst>
   <p:notesMasterIdLst>
-    <p:notesMasterId r:id="rId26"/>
+    <p:notesMasterId r:id="rId24"/>
   </p:notesMasterIdLst>
   <p:sldIdLst>
     <p:sldId id="256" r:id="rId2"/>
@@ -18,20 +18,18 @@
     <p:sldId id="262" r:id="rId9"/>
     <p:sldId id="263" r:id="rId10"/>
     <p:sldId id="264" r:id="rId11"/>
-    <p:sldId id="266" r:id="rId12"/>
-    <p:sldId id="267" r:id="rId13"/>
-    <p:sldId id="268" r:id="rId14"/>
-    <p:sldId id="269" r:id="rId15"/>
-    <p:sldId id="270" r:id="rId16"/>
-    <p:sldId id="271" r:id="rId17"/>
-    <p:sldId id="272" r:id="rId18"/>
-    <p:sldId id="274" r:id="rId19"/>
-    <p:sldId id="273" r:id="rId20"/>
-    <p:sldId id="276" r:id="rId21"/>
-    <p:sldId id="275" r:id="rId22"/>
-    <p:sldId id="278" r:id="rId23"/>
-    <p:sldId id="279" r:id="rId24"/>
-    <p:sldId id="265" r:id="rId25"/>
+    <p:sldId id="267" r:id="rId12"/>
+    <p:sldId id="268" r:id="rId13"/>
+    <p:sldId id="269" r:id="rId14"/>
+    <p:sldId id="270" r:id="rId15"/>
+    <p:sldId id="271" r:id="rId16"/>
+    <p:sldId id="272" r:id="rId17"/>
+    <p:sldId id="274" r:id="rId18"/>
+    <p:sldId id="276" r:id="rId19"/>
+    <p:sldId id="275" r:id="rId20"/>
+    <p:sldId id="278" r:id="rId21"/>
+    <p:sldId id="279" r:id="rId22"/>
+    <p:sldId id="265" r:id="rId23"/>
   </p:sldIdLst>
   <p:sldSz cx="12192000" cy="6858000"/>
   <p:notesSz cx="6858000" cy="9144000"/>
@@ -9562,7 +9560,7 @@
           <a:p>
             <a:fld id="{38A16F2C-4F22-4D6C-9759-7E77A28DB452}" type="datetimeFigureOut">
               <a:rPr lang="it-IT" smtClean="0"/>
-              <a:t>23/02/2026</a:t>
+              <a:t>27/02/2026</a:t>
             </a:fld>
             <a:endParaRPr lang="it-IT"/>
           </a:p>
@@ -9873,22 +9871,6 @@
           <a:bodyPr/>
           <a:lstStyle/>
           <a:p>
-            <a:r>
-              <a:rPr lang="pt-BR" dirty="0"/>
-              <a:t>Tahnk and Welcome to this first lesson of...my name is..but i will introduce myself in a moment</a:t>
-            </a:r>
-          </a:p>
-          <a:p>
-            <a:r>
-              <a:rPr lang="pt-BR" dirty="0"/>
-              <a:t>Introductory lesson</a:t>
-            </a:r>
-          </a:p>
-          <a:p>
-            <a:r>
-              <a:rPr lang="pt-BR" dirty="0"/>
-              <a:t>I will make a case as to why you should be interested and why this course can be different to other subjects</a:t>
-            </a:r>
             <a:endParaRPr lang="it-IT" dirty="0"/>
           </a:p>
         </p:txBody>
@@ -9973,119 +9955,6 @@
           <a:bodyPr/>
           <a:lstStyle/>
           <a:p>
-            <a:pPr marL="0" marR="0" lvl="0" indent="0" algn="l" defTabSz="914400" rtl="0" eaLnBrk="1" fontAlgn="auto" latinLnBrk="0" hangingPunct="1">
-              <a:lnSpc>
-                <a:spcPct val="100000"/>
-              </a:lnSpc>
-              <a:spcBef>
-                <a:spcPts val="0"/>
-              </a:spcBef>
-              <a:spcAft>
-                <a:spcPts val="0"/>
-              </a:spcAft>
-              <a:buClrTx/>
-              <a:buSzTx/>
-              <a:buFontTx/>
-              <a:buNone/>
-              <a:tabLst/>
-              <a:defRPr/>
-            </a:pPr>
-            <a:r>
-              <a:rPr lang="pt-BR" dirty="0"/>
-              <a:t>Cognitive efficiency | Motivated reasoning | Social dynamics | Emotional Mechanisms | Information Environment Effect</a:t>
-            </a:r>
-          </a:p>
-          <a:p>
-            <a:r>
-              <a:rPr lang="pt-BR" dirty="0"/>
-              <a:t>Miserliness = general tendency of people to look for quick solutions (mental shortcuts)</a:t>
-            </a:r>
-          </a:p>
-          <a:p>
-            <a:r>
-              <a:rPr lang="pt-BR" dirty="0"/>
-              <a:t>Daniel Kahnemann Thinking Fast and Slow: system 1 works automatically and quickly, system 2 is an agency choice of effort</a:t>
-            </a:r>
-          </a:p>
-          <a:p>
-            <a:r>
-              <a:rPr lang="pt-BR" dirty="0"/>
-              <a:t>Heuristics = indicators we use to make quick judgement (often wrongly) primitives -&gt; nowadays -&gt; information attention war (Frusciante)</a:t>
-            </a:r>
-          </a:p>
-          <a:p>
-            <a:r>
-              <a:rPr lang="pt-BR" dirty="0"/>
-              <a:t>Confirmation bias = believe information that confirms pre-existing beliefs and reject contrarian information</a:t>
-            </a:r>
-          </a:p>
-          <a:p>
-            <a:r>
-              <a:rPr lang="pt-BR" dirty="0"/>
-              <a:t>Selective exposure = </a:t>
-            </a:r>
-            <a:r>
-              <a:rPr lang="en-US" dirty="0"/>
-              <a:t>tendency to seek out and prefer information that aligns with existing attitudes or beliefs</a:t>
-            </a:r>
-          </a:p>
-          <a:p>
-            <a:r>
-              <a:rPr lang="en-US" dirty="0"/>
-              <a:t>Identity-protection cognition = preference information that connects with what people think they are (their group and community) -&gt; accuracy doesn’t matter, sharing != believing</a:t>
-            </a:r>
-          </a:p>
-          <a:p>
-            <a:r>
-              <a:rPr lang="en-US" dirty="0"/>
-              <a:t>Naïve realism = what we see and perceive is real and corresponds to truth (and others are wrong)</a:t>
-            </a:r>
-            <a:endParaRPr lang="pt-BR" dirty="0"/>
-          </a:p>
-          <a:p>
-            <a:r>
-              <a:rPr lang="en-US" sz="1200" b="0" i="0" kern="1200" dirty="0">
-                <a:solidFill>
-                  <a:schemeClr val="tx1"/>
-                </a:solidFill>
-                <a:effectLst/>
-                <a:latin typeface="+mn-lt"/>
-                <a:ea typeface="+mn-ea"/>
-                <a:cs typeface="+mn-cs"/>
-              </a:rPr>
-              <a:t>Pluralistic ignorance is a lack of understanding about what others in society think and believe.</a:t>
-            </a:r>
-          </a:p>
-          <a:p>
-            <a:r>
-              <a:rPr lang="en-US" sz="1200" b="0" i="0" kern="1200" dirty="0">
-                <a:solidFill>
-                  <a:schemeClr val="tx1"/>
-                </a:solidFill>
-                <a:effectLst/>
-                <a:latin typeface="+mn-lt"/>
-                <a:ea typeface="+mn-ea"/>
-                <a:cs typeface="+mn-cs"/>
-              </a:rPr>
-              <a:t>Illusory Truth Effect = Repeated statements receive higher truth ratings than new statements (Knowledge does not protect against it)</a:t>
-            </a:r>
-          </a:p>
-          <a:p>
-            <a:r>
-              <a:rPr lang="en-US" sz="1200" b="0" i="0" kern="1200" dirty="0">
-                <a:solidFill>
-                  <a:schemeClr val="tx1"/>
-                </a:solidFill>
-                <a:effectLst/>
-                <a:latin typeface="+mn-lt"/>
-                <a:ea typeface="+mn-ea"/>
-                <a:cs typeface="+mn-cs"/>
-              </a:rPr>
-              <a:t>Bandwagon effect = join what they perceive to be existing or expected majorities or dominant positions in society.</a:t>
-            </a:r>
-            <a:endParaRPr lang="pt-BR" dirty="0"/>
-          </a:p>
-          <a:p>
             <a:endParaRPr lang="it-IT" dirty="0"/>
           </a:p>
         </p:txBody>
@@ -10131,13 +10000,7 @@
   <p:cSld>
     <p:spTree>
       <p:nvGrpSpPr>
-        <p:cNvPr id="1" name="">
-          <a:extLst>
-            <a:ext uri="{FF2B5EF4-FFF2-40B4-BE49-F238E27FC236}">
-              <a16:creationId xmlns:a16="http://schemas.microsoft.com/office/drawing/2014/main" id="{53D7CE46-A9AA-3242-2636-C61D324161F2}"/>
-            </a:ext>
-          </a:extLst>
-        </p:cNvPr>
+        <p:cNvPr id="1" name=""/>
         <p:cNvGrpSpPr/>
         <p:nvPr/>
       </p:nvGrpSpPr>
@@ -10151,13 +10014,7 @@
       </p:grpSpPr>
       <p:sp>
         <p:nvSpPr>
-          <p:cNvPr id="2" name="Segnaposto immagine diapositiva 1">
-            <a:extLst>
-              <a:ext uri="{FF2B5EF4-FFF2-40B4-BE49-F238E27FC236}">
-                <a16:creationId xmlns:a16="http://schemas.microsoft.com/office/drawing/2014/main" id="{8E1CD87B-4FDA-1720-A5F0-D2D095668323}"/>
-              </a:ext>
-            </a:extLst>
-          </p:cNvPr>
+          <p:cNvPr id="2" name="Segnaposto immagine diapositiva 1"/>
           <p:cNvSpPr>
             <a:spLocks noGrp="1" noRot="1" noChangeAspect="1"/>
           </p:cNvSpPr>
@@ -10169,13 +10026,7 @@
       </p:sp>
       <p:sp>
         <p:nvSpPr>
-          <p:cNvPr id="3" name="Segnaposto note 2">
-            <a:extLst>
-              <a:ext uri="{FF2B5EF4-FFF2-40B4-BE49-F238E27FC236}">
-                <a16:creationId xmlns:a16="http://schemas.microsoft.com/office/drawing/2014/main" id="{9B90F62F-40BD-C434-5393-37D8F6453374}"/>
-              </a:ext>
-            </a:extLst>
-          </p:cNvPr>
+          <p:cNvPr id="3" name="Segnaposto note 2"/>
           <p:cNvSpPr>
             <a:spLocks noGrp="1"/>
           </p:cNvSpPr>
@@ -10194,13 +10045,7 @@
       </p:sp>
       <p:sp>
         <p:nvSpPr>
-          <p:cNvPr id="4" name="Segnaposto numero diapositiva 3">
-            <a:extLst>
-              <a:ext uri="{FF2B5EF4-FFF2-40B4-BE49-F238E27FC236}">
-                <a16:creationId xmlns:a16="http://schemas.microsoft.com/office/drawing/2014/main" id="{D0774A11-DB07-F9AB-D121-FC67E3BA97AE}"/>
-              </a:ext>
-            </a:extLst>
-          </p:cNvPr>
+          <p:cNvPr id="4" name="Segnaposto numero diapositiva 3"/>
           <p:cNvSpPr>
             <a:spLocks noGrp="1"/>
           </p:cNvSpPr>
@@ -10215,7 +10060,7 @@
           <a:p>
             <a:fld id="{99DB328D-763F-4F02-A81E-9F12D2471F2D}" type="slidenum">
               <a:rPr lang="it-IT" smtClean="0"/>
-              <a:t>11</a:t>
+              <a:t>12</a:t>
             </a:fld>
             <a:endParaRPr lang="it-IT"/>
           </a:p>
@@ -10224,7 +10069,7 @@
     </p:spTree>
     <p:extLst>
       <p:ext uri="{BB962C8B-B14F-4D97-AF65-F5344CB8AC3E}">
-        <p14:creationId xmlns:p14="http://schemas.microsoft.com/office/powerpoint/2010/main" val="402772674"/>
+        <p14:creationId xmlns:p14="http://schemas.microsoft.com/office/powerpoint/2010/main" val="980671329"/>
       </p:ext>
     </p:extLst>
   </p:cSld>
@@ -10278,10 +10123,6 @@
           <a:bodyPr/>
           <a:lstStyle/>
           <a:p>
-            <a:r>
-              <a:rPr lang="pt-BR" dirty="0"/>
-              <a:t>Continued-influence effect</a:t>
-            </a:r>
             <a:endParaRPr lang="it-IT" dirty="0"/>
           </a:p>
         </p:txBody>
@@ -10303,7 +10144,7 @@
           <a:p>
             <a:fld id="{99DB328D-763F-4F02-A81E-9F12D2471F2D}" type="slidenum">
               <a:rPr lang="it-IT" smtClean="0"/>
-              <a:t>13</a:t>
+              <a:t>16</a:t>
             </a:fld>
             <a:endParaRPr lang="it-IT"/>
           </a:p>
@@ -10312,7 +10153,7 @@
     </p:spTree>
     <p:extLst>
       <p:ext uri="{BB962C8B-B14F-4D97-AF65-F5344CB8AC3E}">
-        <p14:creationId xmlns:p14="http://schemas.microsoft.com/office/powerpoint/2010/main" val="980671329"/>
+        <p14:creationId xmlns:p14="http://schemas.microsoft.com/office/powerpoint/2010/main" val="723117605"/>
       </p:ext>
     </p:extLst>
   </p:cSld>
@@ -10366,10 +10207,6 @@
           <a:bodyPr/>
           <a:lstStyle/>
           <a:p>
-            <a:r>
-              <a:rPr lang="pt-BR" dirty="0"/>
-              <a:t>Yoel Roth (Twitter Integrity Team) 2020 Donald Trump mail ballot</a:t>
-            </a:r>
             <a:endParaRPr lang="it-IT" dirty="0"/>
           </a:p>
         </p:txBody>
@@ -10400,7 +10237,7 @@
     </p:spTree>
     <p:extLst>
       <p:ext uri="{BB962C8B-B14F-4D97-AF65-F5344CB8AC3E}">
-        <p14:creationId xmlns:p14="http://schemas.microsoft.com/office/powerpoint/2010/main" val="723117605"/>
+        <p14:creationId xmlns:p14="http://schemas.microsoft.com/office/powerpoint/2010/main" val="788680520"/>
       </p:ext>
     </p:extLst>
   </p:cSld>
@@ -10411,233 +10248,6 @@
 </file>
 
 <file path=ppt/notesSlides/notesSlide14.xml><?xml version="1.0" encoding="utf-8"?>
-<p:notes xmlns:a="http://schemas.openxmlformats.org/drawingml/2006/main" xmlns:r="http://schemas.openxmlformats.org/officeDocument/2006/relationships" xmlns:p="http://schemas.openxmlformats.org/presentationml/2006/main">
-  <p:cSld>
-    <p:spTree>
-      <p:nvGrpSpPr>
-        <p:cNvPr id="1" name=""/>
-        <p:cNvGrpSpPr/>
-        <p:nvPr/>
-      </p:nvGrpSpPr>
-      <p:grpSpPr>
-        <a:xfrm>
-          <a:off x="0" y="0"/>
-          <a:ext cx="0" cy="0"/>
-          <a:chOff x="0" y="0"/>
-          <a:chExt cx="0" cy="0"/>
-        </a:xfrm>
-      </p:grpSpPr>
-      <p:sp>
-        <p:nvSpPr>
-          <p:cNvPr id="2" name="Segnaposto immagine diapositiva 1"/>
-          <p:cNvSpPr>
-            <a:spLocks noGrp="1" noRot="1" noChangeAspect="1"/>
-          </p:cNvSpPr>
-          <p:nvPr>
-            <p:ph type="sldImg"/>
-          </p:nvPr>
-        </p:nvSpPr>
-        <p:spPr/>
-      </p:sp>
-      <p:sp>
-        <p:nvSpPr>
-          <p:cNvPr id="3" name="Segnaposto note 2"/>
-          <p:cNvSpPr>
-            <a:spLocks noGrp="1"/>
-          </p:cNvSpPr>
-          <p:nvPr>
-            <p:ph type="body" idx="1"/>
-          </p:nvPr>
-        </p:nvSpPr>
-        <p:spPr/>
-        <p:txBody>
-          <a:bodyPr/>
-          <a:lstStyle/>
-          <a:p>
-            <a:r>
-              <a:rPr lang="pt-BR" dirty="0"/>
-              <a:t>Cambridge analytica</a:t>
-            </a:r>
-          </a:p>
-          <a:p>
-            <a:r>
-              <a:rPr lang="pt-BR" dirty="0"/>
-              <a:t>Salvi et al.</a:t>
-            </a:r>
-            <a:endParaRPr lang="it-IT" dirty="0"/>
-          </a:p>
-        </p:txBody>
-      </p:sp>
-      <p:sp>
-        <p:nvSpPr>
-          <p:cNvPr id="4" name="Segnaposto numero diapositiva 3"/>
-          <p:cNvSpPr>
-            <a:spLocks noGrp="1"/>
-          </p:cNvSpPr>
-          <p:nvPr>
-            <p:ph type="sldNum" sz="quarter" idx="5"/>
-          </p:nvPr>
-        </p:nvSpPr>
-        <p:spPr/>
-        <p:txBody>
-          <a:bodyPr/>
-          <a:lstStyle/>
-          <a:p>
-            <a:fld id="{99DB328D-763F-4F02-A81E-9F12D2471F2D}" type="slidenum">
-              <a:rPr lang="it-IT" smtClean="0"/>
-              <a:t>18</a:t>
-            </a:fld>
-            <a:endParaRPr lang="it-IT"/>
-          </a:p>
-        </p:txBody>
-      </p:sp>
-    </p:spTree>
-    <p:extLst>
-      <p:ext uri="{BB962C8B-B14F-4D97-AF65-F5344CB8AC3E}">
-        <p14:creationId xmlns:p14="http://schemas.microsoft.com/office/powerpoint/2010/main" val="788680520"/>
-      </p:ext>
-    </p:extLst>
-  </p:cSld>
-  <p:clrMapOvr>
-    <a:masterClrMapping/>
-  </p:clrMapOvr>
-</p:notes>
-</file>
-
-<file path=ppt/notesSlides/notesSlide15.xml><?xml version="1.0" encoding="utf-8"?>
-<p:notes xmlns:a="http://schemas.openxmlformats.org/drawingml/2006/main" xmlns:r="http://schemas.openxmlformats.org/officeDocument/2006/relationships" xmlns:p="http://schemas.openxmlformats.org/presentationml/2006/main">
-  <p:cSld>
-    <p:spTree>
-      <p:nvGrpSpPr>
-        <p:cNvPr id="1" name=""/>
-        <p:cNvGrpSpPr/>
-        <p:nvPr/>
-      </p:nvGrpSpPr>
-      <p:grpSpPr>
-        <a:xfrm>
-          <a:off x="0" y="0"/>
-          <a:ext cx="0" cy="0"/>
-          <a:chOff x="0" y="0"/>
-          <a:chExt cx="0" cy="0"/>
-        </a:xfrm>
-      </p:grpSpPr>
-      <p:sp>
-        <p:nvSpPr>
-          <p:cNvPr id="2" name="Segnaposto immagine diapositiva 1"/>
-          <p:cNvSpPr>
-            <a:spLocks noGrp="1" noRot="1" noChangeAspect="1"/>
-          </p:cNvSpPr>
-          <p:nvPr>
-            <p:ph type="sldImg"/>
-          </p:nvPr>
-        </p:nvSpPr>
-        <p:spPr/>
-      </p:sp>
-      <p:sp>
-        <p:nvSpPr>
-          <p:cNvPr id="3" name="Segnaposto note 2"/>
-          <p:cNvSpPr>
-            <a:spLocks noGrp="1"/>
-          </p:cNvSpPr>
-          <p:nvPr>
-            <p:ph type="body" idx="1"/>
-          </p:nvPr>
-        </p:nvSpPr>
-        <p:spPr/>
-        <p:txBody>
-          <a:bodyPr/>
-          <a:lstStyle/>
-          <a:p>
-            <a:r>
-              <a:rPr lang="en-US" sz="1200" b="0" i="0" kern="1200" dirty="0" err="1">
-                <a:solidFill>
-                  <a:schemeClr val="tx1"/>
-                </a:solidFill>
-                <a:effectLst/>
-                <a:latin typeface="+mn-lt"/>
-                <a:ea typeface="+mn-ea"/>
-                <a:cs typeface="+mn-cs"/>
-              </a:rPr>
-              <a:t>Prebunking</a:t>
-            </a:r>
-            <a:r>
-              <a:rPr lang="en-US" sz="1200" b="0" i="0" kern="1200" dirty="0">
-                <a:solidFill>
-                  <a:schemeClr val="tx1"/>
-                </a:solidFill>
-                <a:effectLst/>
-                <a:latin typeface="+mn-lt"/>
-                <a:ea typeface="+mn-ea"/>
-                <a:cs typeface="+mn-cs"/>
-              </a:rPr>
-              <a:t> seeks to help people recognize and resist subsequently encountered misinformation, even if it is novel. </a:t>
-            </a:r>
-          </a:p>
-          <a:p>
-            <a:r>
-              <a:rPr lang="en-US" sz="1200" b="0" i="0" kern="1200" dirty="0">
-                <a:solidFill>
-                  <a:schemeClr val="tx1"/>
-                </a:solidFill>
-                <a:effectLst/>
-                <a:latin typeface="+mn-lt"/>
-                <a:ea typeface="+mn-ea"/>
-                <a:cs typeface="+mn-cs"/>
-              </a:rPr>
-              <a:t>Debunking emphasizes responding to specific misinformation after exposure to demonstrate why it is false.</a:t>
-            </a:r>
-          </a:p>
-          <a:p>
-            <a:r>
-              <a:rPr lang="pt-BR" dirty="0"/>
-              <a:t>Classifiers are closer to debunking than prebunking since they are reactive, it activates after fake news is created, but they can be part of prebunking interventions if coadiuvated with e.g., warnings, friction, education interventions after detection</a:t>
-            </a:r>
-          </a:p>
-          <a:p>
-            <a:r>
-              <a:rPr lang="pt-BR" dirty="0"/>
-              <a:t>Why prebunking (i.e., inoculation) is usually preferred: more generalizable, post-inoculation talk but it’s slower, more expensive</a:t>
-            </a:r>
-          </a:p>
-        </p:txBody>
-      </p:sp>
-      <p:sp>
-        <p:nvSpPr>
-          <p:cNvPr id="4" name="Segnaposto numero diapositiva 3"/>
-          <p:cNvSpPr>
-            <a:spLocks noGrp="1"/>
-          </p:cNvSpPr>
-          <p:nvPr>
-            <p:ph type="sldNum" sz="quarter" idx="5"/>
-          </p:nvPr>
-        </p:nvSpPr>
-        <p:spPr/>
-        <p:txBody>
-          <a:bodyPr/>
-          <a:lstStyle/>
-          <a:p>
-            <a:fld id="{99DB328D-763F-4F02-A81E-9F12D2471F2D}" type="slidenum">
-              <a:rPr lang="it-IT" smtClean="0"/>
-              <a:t>19</a:t>
-            </a:fld>
-            <a:endParaRPr lang="it-IT"/>
-          </a:p>
-        </p:txBody>
-      </p:sp>
-    </p:spTree>
-    <p:extLst>
-      <p:ext uri="{BB962C8B-B14F-4D97-AF65-F5344CB8AC3E}">
-        <p14:creationId xmlns:p14="http://schemas.microsoft.com/office/powerpoint/2010/main" val="1642574119"/>
-      </p:ext>
-    </p:extLst>
-  </p:cSld>
-  <p:clrMapOvr>
-    <a:masterClrMapping/>
-  </p:clrMapOvr>
-</p:notes>
-</file>
-
-<file path=ppt/notesSlides/notesSlide16.xml><?xml version="1.0" encoding="utf-8"?>
 <p:notes xmlns:a="http://schemas.openxmlformats.org/drawingml/2006/main" xmlns:r="http://schemas.openxmlformats.org/officeDocument/2006/relationships" xmlns:p="http://schemas.openxmlformats.org/presentationml/2006/main">
   <p:cSld>
     <p:spTree>
@@ -10699,66 +10309,6 @@
           <a:bodyPr/>
           <a:lstStyle/>
           <a:p>
-            <a:r>
-              <a:rPr lang="en-US" sz="1200" b="0" i="0" kern="1200" dirty="0" err="1">
-                <a:solidFill>
-                  <a:schemeClr val="tx1"/>
-                </a:solidFill>
-                <a:effectLst/>
-                <a:latin typeface="+mn-lt"/>
-                <a:ea typeface="+mn-ea"/>
-                <a:cs typeface="+mn-cs"/>
-              </a:rPr>
-              <a:t>Prebunking</a:t>
-            </a:r>
-            <a:r>
-              <a:rPr lang="en-US" sz="1200" b="0" i="0" kern="1200" dirty="0">
-                <a:solidFill>
-                  <a:schemeClr val="tx1"/>
-                </a:solidFill>
-                <a:effectLst/>
-                <a:latin typeface="+mn-lt"/>
-                <a:ea typeface="+mn-ea"/>
-                <a:cs typeface="+mn-cs"/>
-              </a:rPr>
-              <a:t> seeks to help people recognize and resist subsequently encountered misinformation, even if it is novel. </a:t>
-            </a:r>
-          </a:p>
-          <a:p>
-            <a:r>
-              <a:rPr lang="en-US" sz="1200" b="0" i="0" kern="1200" dirty="0">
-                <a:solidFill>
-                  <a:schemeClr val="tx1"/>
-                </a:solidFill>
-                <a:effectLst/>
-                <a:latin typeface="+mn-lt"/>
-                <a:ea typeface="+mn-ea"/>
-                <a:cs typeface="+mn-cs"/>
-              </a:rPr>
-              <a:t>Debunking emphasizes responding to specific misinformation after exposure to demonstrate why it is false.</a:t>
-            </a:r>
-          </a:p>
-          <a:p>
-            <a:r>
-              <a:rPr lang="pt-BR" dirty="0"/>
-              <a:t>Classifiers are closer to debunking than prebunking since they are reactive, it activates after fake news is created</a:t>
-            </a:r>
-          </a:p>
-          <a:p>
-            <a:r>
-              <a:rPr lang="pt-BR" dirty="0"/>
-              <a:t>Why prebunking (i.e., inoculation) is usually preferred: more generalizable, post-inoculation talk but it’s slower, more expensive</a:t>
-            </a:r>
-          </a:p>
-          <a:p>
-            <a:r>
-              <a:rPr lang="en-US" i="1" dirty="0"/>
-              <a:t>debunking alone doesn't work</a:t>
-            </a:r>
-            <a:r>
-              <a:rPr lang="en-US" dirty="0"/>
-              <a:t>, and effective interventions need to target the psychological mechanisms underneath.</a:t>
-            </a:r>
             <a:endParaRPr lang="pt-BR" dirty="0"/>
           </a:p>
         </p:txBody>
@@ -10786,7 +10336,7 @@
           <a:p>
             <a:fld id="{99DB328D-763F-4F02-A81E-9F12D2471F2D}" type="slidenum">
               <a:rPr lang="it-IT" smtClean="0"/>
-              <a:t>20</a:t>
+              <a:t>18</a:t>
             </a:fld>
             <a:endParaRPr lang="it-IT"/>
           </a:p>
@@ -10805,7 +10355,7 @@
 </p:notes>
 </file>
 
-<file path=ppt/notesSlides/notesSlide17.xml><?xml version="1.0" encoding="utf-8"?>
+<file path=ppt/notesSlides/notesSlide15.xml><?xml version="1.0" encoding="utf-8"?>
 <p:notes xmlns:a="http://schemas.openxmlformats.org/drawingml/2006/main" xmlns:r="http://schemas.openxmlformats.org/officeDocument/2006/relationships" xmlns:p="http://schemas.openxmlformats.org/presentationml/2006/main">
   <p:cSld>
     <p:spTree>
@@ -10867,77 +10417,6 @@
           <a:bodyPr/>
           <a:lstStyle/>
           <a:p>
-            <a:r>
-              <a:rPr lang="pt-BR" dirty="0"/>
-              <a:t>Mind as in </a:t>
-            </a:r>
-            <a:r>
-              <a:rPr lang="it-IT" dirty="0" err="1"/>
-              <a:t>psychological</a:t>
-            </a:r>
-            <a:r>
-              <a:rPr lang="it-IT" dirty="0"/>
-              <a:t> and cognitive </a:t>
-            </a:r>
-            <a:r>
-              <a:rPr lang="it-IT" dirty="0" err="1"/>
-              <a:t>construct</a:t>
-            </a:r>
-            <a:r>
-              <a:rPr lang="it-IT" dirty="0"/>
-              <a:t> </a:t>
-            </a:r>
-            <a:r>
-              <a:rPr lang="it-IT" dirty="0" err="1"/>
-              <a:t>representation</a:t>
-            </a:r>
-            <a:endParaRPr lang="it-IT" dirty="0"/>
-          </a:p>
-          <a:p>
-            <a:pPr marL="0" marR="0" lvl="0" indent="0" algn="l" defTabSz="914400" rtl="0" eaLnBrk="1" fontAlgn="auto" latinLnBrk="0" hangingPunct="1">
-              <a:lnSpc>
-                <a:spcPct val="100000"/>
-              </a:lnSpc>
-              <a:spcBef>
-                <a:spcPts val="0"/>
-              </a:spcBef>
-              <a:spcAft>
-                <a:spcPts val="0"/>
-              </a:spcAft>
-              <a:buClrTx/>
-              <a:buSzTx/>
-              <a:buFontTx/>
-              <a:buNone/>
-              <a:tabLst/>
-              <a:defRPr/>
-            </a:pPr>
-            <a:r>
-              <a:rPr lang="en-US" dirty="0"/>
-              <a:t>The idea is to leverage computation (how?) to </a:t>
-            </a:r>
-            <a:r>
-              <a:rPr lang="en-US" dirty="0" err="1"/>
-              <a:t>analyse</a:t>
-            </a:r>
-            <a:r>
-              <a:rPr lang="en-US" dirty="0"/>
-              <a:t> how psychology manifests in language (go through Venn)</a:t>
-            </a:r>
-            <a:endParaRPr lang="it-IT" dirty="0"/>
-          </a:p>
-          <a:p>
-            <a:r>
-              <a:rPr lang="en-US" dirty="0"/>
-              <a:t>Language reveals: Identity Emotions Moral values Beliefs Cognitive style</a:t>
-            </a:r>
-          </a:p>
-          <a:p>
-            <a:r>
-              <a:rPr lang="en-US" dirty="0"/>
-              <a:t>Text becomes: A behavioral trace of mental processes.</a:t>
-            </a:r>
-          </a:p>
-          <a:p>
             <a:endParaRPr lang="it-IT" dirty="0"/>
           </a:p>
         </p:txBody>
@@ -10965,7 +10444,7 @@
           <a:p>
             <a:fld id="{99DB328D-763F-4F02-A81E-9F12D2471F2D}" type="slidenum">
               <a:rPr lang="it-IT" smtClean="0"/>
-              <a:t>21</a:t>
+              <a:t>19</a:t>
             </a:fld>
             <a:endParaRPr lang="it-IT"/>
           </a:p>
@@ -10984,7 +10463,7 @@
 </p:notes>
 </file>
 
-<file path=ppt/notesSlides/notesSlide18.xml><?xml version="1.0" encoding="utf-8"?>
+<file path=ppt/notesSlides/notesSlide16.xml><?xml version="1.0" encoding="utf-8"?>
 <p:notes xmlns:a="http://schemas.openxmlformats.org/drawingml/2006/main" xmlns:r="http://schemas.openxmlformats.org/officeDocument/2006/relationships" xmlns:p="http://schemas.openxmlformats.org/presentationml/2006/main">
   <p:cSld>
     <p:spTree>
@@ -11052,7 +10531,7 @@
           <a:p>
             <a:fld id="{99DB328D-763F-4F02-A81E-9F12D2471F2D}" type="slidenum">
               <a:rPr lang="it-IT" smtClean="0"/>
-              <a:t>24</a:t>
+              <a:t>22</a:t>
             </a:fld>
             <a:endParaRPr lang="it-IT"/>
           </a:p>
@@ -11115,22 +10594,7 @@
           <a:bodyPr/>
           <a:lstStyle/>
           <a:p>
-            <a:r>
-              <a:rPr lang="pt-BR" dirty="0"/>
-              <a:t>With a twist because we will focus the scope of NLP to specific uses</a:t>
-            </a:r>
-          </a:p>
-          <a:p>
-            <a:r>
-              <a:rPr lang="pt-BR" dirty="0"/>
-              <a:t>How many of you have studied NLP?</a:t>
-            </a:r>
-          </a:p>
-          <a:p>
-            <a:r>
-              <a:rPr lang="pt-BR" dirty="0"/>
-              <a:t>Show Venn</a:t>
-            </a:r>
+            <a:endParaRPr lang="pt-BR" dirty="0"/>
           </a:p>
         </p:txBody>
       </p:sp>
@@ -11232,129 +10696,6 @@
           <a:bodyPr/>
           <a:lstStyle/>
           <a:p>
-            <a:r>
-              <a:rPr lang="pt-BR" dirty="0"/>
-              <a:t>Why did you enroll in ths course?</a:t>
-            </a:r>
-          </a:p>
-          <a:p>
-            <a:r>
-              <a:rPr lang="pt-BR" dirty="0"/>
-              <a:t>When i designed I wanted to have a context in mind: misinformation</a:t>
-            </a:r>
-          </a:p>
-          <a:p>
-            <a:r>
-              <a:rPr lang="pt-BR" dirty="0"/>
-              <a:t>First, does it matter? The answer to the end of this lesson, but there is one problem that touches all three aspects: misinformation. We won’t talk about it directly, but it will permeate this entire course</a:t>
-            </a:r>
-          </a:p>
-          <a:p>
-            <a:r>
-              <a:rPr lang="it-IT" dirty="0" err="1"/>
-              <a:t>Often</a:t>
-            </a:r>
-            <a:r>
-              <a:rPr lang="it-IT" dirty="0"/>
-              <a:t> times, </a:t>
-            </a:r>
-            <a:r>
-              <a:rPr lang="it-IT" dirty="0" err="1"/>
-              <a:t>especially</a:t>
-            </a:r>
-            <a:r>
-              <a:rPr lang="it-IT" dirty="0"/>
-              <a:t> in NLP, </a:t>
-            </a:r>
-            <a:r>
-              <a:rPr lang="it-IT" dirty="0" err="1"/>
-              <a:t>misinformation</a:t>
-            </a:r>
-            <a:r>
-              <a:rPr lang="it-IT" dirty="0"/>
-              <a:t> </a:t>
-            </a:r>
-            <a:r>
-              <a:rPr lang="it-IT" dirty="0" err="1"/>
-              <a:t>is</a:t>
-            </a:r>
-            <a:r>
-              <a:rPr lang="it-IT" dirty="0"/>
-              <a:t> </a:t>
-            </a:r>
-            <a:r>
-              <a:rPr lang="it-IT" dirty="0" err="1"/>
-              <a:t>approached</a:t>
-            </a:r>
-            <a:r>
-              <a:rPr lang="it-IT" dirty="0"/>
-              <a:t> from a </a:t>
-            </a:r>
-            <a:r>
-              <a:rPr lang="it-IT" dirty="0" err="1"/>
-              <a:t>detection</a:t>
-            </a:r>
-            <a:r>
-              <a:rPr lang="it-IT" dirty="0"/>
-              <a:t> </a:t>
-            </a:r>
-            <a:r>
-              <a:rPr lang="it-IT" dirty="0" err="1"/>
-              <a:t>standpoint</a:t>
-            </a:r>
-            <a:r>
-              <a:rPr lang="it-IT" dirty="0"/>
-              <a:t>, </a:t>
-            </a:r>
-            <a:r>
-              <a:rPr lang="it-IT" dirty="0" err="1"/>
-              <a:t>here</a:t>
-            </a:r>
-            <a:r>
-              <a:rPr lang="it-IT" dirty="0"/>
-              <a:t> </a:t>
-            </a:r>
-            <a:r>
-              <a:rPr lang="it-IT" dirty="0" err="1"/>
-              <a:t>we</a:t>
-            </a:r>
-            <a:r>
-              <a:rPr lang="it-IT" dirty="0"/>
-              <a:t> are </a:t>
-            </a:r>
-            <a:r>
-              <a:rPr lang="it-IT" dirty="0" err="1"/>
-              <a:t>going</a:t>
-            </a:r>
-            <a:r>
-              <a:rPr lang="it-IT" dirty="0"/>
-              <a:t> to shift the focus a bit (more on </a:t>
-            </a:r>
-            <a:r>
-              <a:rPr lang="it-IT" dirty="0" err="1"/>
-              <a:t>that</a:t>
-            </a:r>
-            <a:r>
-              <a:rPr lang="it-IT" dirty="0"/>
-              <a:t> </a:t>
-            </a:r>
-            <a:r>
-              <a:rPr lang="it-IT" dirty="0" err="1"/>
-              <a:t>later</a:t>
-            </a:r>
-            <a:r>
-              <a:rPr lang="it-IT" dirty="0"/>
-              <a:t>)</a:t>
-            </a:r>
-          </a:p>
-          <a:p>
-            <a:endParaRPr lang="en-US" dirty="0"/>
-          </a:p>
-          <a:p>
-            <a:r>
-              <a:rPr lang="en-US" dirty="0"/>
-              <a:t>why am I the one teaching this</a:t>
-            </a:r>
             <a:endParaRPr lang="it-IT" dirty="0"/>
           </a:p>
         </p:txBody>
@@ -11445,145 +10786,6 @@
           <a:bodyPr/>
           <a:lstStyle/>
           <a:p>
-            <a:r>
-              <a:rPr lang="it-IT" b="1" dirty="0">
-                <a:effectLst/>
-              </a:rPr>
-              <a:t>Session 1 – </a:t>
-            </a:r>
-            <a:r>
-              <a:rPr lang="it-IT" b="1" dirty="0" err="1">
-                <a:effectLst/>
-              </a:rPr>
-              <a:t>Introduction</a:t>
-            </a:r>
-            <a:r>
-              <a:rPr lang="it-IT" b="1" dirty="0">
-                <a:effectLst/>
-              </a:rPr>
-              <a:t> &amp; </a:t>
-            </a:r>
-            <a:r>
-              <a:rPr lang="it-IT" b="1" dirty="0" err="1">
-                <a:effectLst/>
-              </a:rPr>
-              <a:t>Motivation</a:t>
-            </a:r>
-            <a:endParaRPr lang="it-IT" b="1" dirty="0">
-              <a:effectLst/>
-            </a:endParaRPr>
-          </a:p>
-          <a:p>
-            <a:r>
-              <a:rPr lang="it-IT" b="1" dirty="0">
-                <a:effectLst/>
-              </a:rPr>
-              <a:t>Session 2 – Data Collection &amp; Corpus </a:t>
-            </a:r>
-            <a:r>
-              <a:rPr lang="it-IT" b="1" dirty="0" err="1">
-                <a:effectLst/>
-              </a:rPr>
-              <a:t>Creation</a:t>
-            </a:r>
-            <a:endParaRPr lang="it-IT" b="1" dirty="0">
-              <a:effectLst/>
-            </a:endParaRPr>
-          </a:p>
-          <a:p>
-            <a:r>
-              <a:rPr lang="en-US" b="1" dirty="0">
-                <a:effectLst/>
-              </a:rPr>
-              <a:t>Session 3 – Data Exploration &amp; Basic Topic Modeling</a:t>
-            </a:r>
-          </a:p>
-          <a:p>
-            <a:r>
-              <a:rPr lang="en-US" b="1" dirty="0">
-                <a:effectLst/>
-              </a:rPr>
-              <a:t>Then more advanced textual techniques</a:t>
-            </a:r>
-            <a:br>
-              <a:rPr lang="en-US" b="1" dirty="0">
-                <a:effectLst/>
-              </a:rPr>
-            </a:br>
-            <a:r>
-              <a:rPr lang="it-IT" b="1" dirty="0">
-                <a:effectLst/>
-              </a:rPr>
-              <a:t>Session 4 – Lexicon-</a:t>
-            </a:r>
-            <a:r>
-              <a:rPr lang="it-IT" b="1" dirty="0" err="1">
-                <a:effectLst/>
-              </a:rPr>
-              <a:t>Based</a:t>
-            </a:r>
-            <a:r>
-              <a:rPr lang="it-IT" b="1" dirty="0">
-                <a:effectLst/>
-              </a:rPr>
-              <a:t> </a:t>
-            </a:r>
-            <a:r>
-              <a:rPr lang="it-IT" b="1" dirty="0" err="1">
-                <a:effectLst/>
-              </a:rPr>
-              <a:t>Measurement</a:t>
-            </a:r>
-            <a:endParaRPr lang="it-IT" b="1" dirty="0">
-              <a:effectLst/>
-            </a:endParaRPr>
-          </a:p>
-          <a:p>
-            <a:r>
-              <a:rPr lang="en-US" b="1" dirty="0">
-                <a:effectLst/>
-              </a:rPr>
-              <a:t>Session 5 - Vector Spaces &amp; Embeddings + </a:t>
-            </a:r>
-            <a:r>
-              <a:rPr lang="en-US" b="1" dirty="0" err="1">
-                <a:effectLst/>
-              </a:rPr>
-              <a:t>DDr</a:t>
-            </a:r>
-            <a:r>
-              <a:rPr lang="en-US" b="1" dirty="0">
-                <a:effectLst/>
-              </a:rPr>
-              <a:t> + CCR + Anchored + </a:t>
-            </a:r>
-            <a:r>
-              <a:rPr lang="en-US" b="1" dirty="0" err="1">
-                <a:effectLst/>
-              </a:rPr>
-              <a:t>Bertopic</a:t>
-            </a:r>
-            <a:endParaRPr lang="en-US" b="1" dirty="0">
-              <a:effectLst/>
-            </a:endParaRPr>
-          </a:p>
-          <a:p>
-            <a:r>
-              <a:rPr lang="en-US" b="1" dirty="0">
-                <a:effectLst/>
-              </a:rPr>
-              <a:t>Session 10 – Comparing Groups with Text-Derived Measures</a:t>
-            </a:r>
-          </a:p>
-          <a:p>
-            <a:r>
-              <a:rPr lang="en-US" b="1" dirty="0">
-                <a:effectLst/>
-              </a:rPr>
-              <a:t>Session 11 – Modeling Dependencies &amp; Counts</a:t>
-            </a:r>
-          </a:p>
-          <a:p>
             <a:endParaRPr lang="it-IT" dirty="0"/>
           </a:p>
         </p:txBody>
@@ -11668,10 +10870,6 @@
           <a:bodyPr/>
           <a:lstStyle/>
           <a:p>
-            <a:r>
-              <a:rPr lang="pt-BR" dirty="0"/>
-              <a:t>This is where I do have questions for you</a:t>
-            </a:r>
             <a:endParaRPr lang="it-IT" dirty="0"/>
           </a:p>
         </p:txBody>
@@ -11756,69 +10954,6 @@
           <a:bodyPr/>
           <a:lstStyle/>
           <a:p>
-            <a:r>
-              <a:rPr lang="pt-BR" dirty="0"/>
-              <a:t>First of all, what is misinformation?</a:t>
-            </a:r>
-            <a:r>
-              <a:rPr lang="it-IT" dirty="0"/>
-              <a:t> = false,” “inaccurate,” or “</a:t>
-            </a:r>
-            <a:r>
-              <a:rPr lang="it-IT" dirty="0" err="1"/>
-              <a:t>incorrect”information</a:t>
-            </a:r>
-            <a:endParaRPr lang="it-IT" dirty="0"/>
-          </a:p>
-          <a:p>
-            <a:r>
-              <a:rPr lang="it-IT" dirty="0" err="1"/>
-              <a:t>Disinformation</a:t>
-            </a:r>
-            <a:r>
-              <a:rPr lang="it-IT" dirty="0"/>
-              <a:t> = </a:t>
-            </a:r>
-            <a:r>
-              <a:rPr lang="en-US" dirty="0"/>
-              <a:t>false information that is also described as being intentionally shared</a:t>
-            </a:r>
-          </a:p>
-          <a:p>
-            <a:r>
-              <a:rPr lang="en-US" dirty="0"/>
-              <a:t>Jayson Blair</a:t>
-            </a:r>
-          </a:p>
-          <a:p>
-            <a:r>
-              <a:rPr lang="pt-BR" dirty="0"/>
-              <a:t>Malinformation = </a:t>
-            </a:r>
-            <a:r>
-              <a:rPr lang="en-US" dirty="0"/>
-              <a:t> Information shared for malicious ends (not necessarily false, i.e., doxing)</a:t>
-            </a:r>
-          </a:p>
-          <a:p>
-            <a:r>
-              <a:rPr lang="en-US" dirty="0"/>
-              <a:t>Fake news = similar to disinformation, news that is intentional and verifiably false</a:t>
-            </a:r>
-          </a:p>
-          <a:p>
-            <a:r>
-              <a:rPr lang="en-US" dirty="0"/>
-              <a:t>Rumor = unverified and instrumentally relevant information state-</a:t>
-            </a:r>
-            <a:r>
-              <a:rPr lang="en-US" dirty="0" err="1"/>
-              <a:t>ments</a:t>
-            </a:r>
-            <a:r>
-              <a:rPr lang="en-US" dirty="0"/>
-              <a:t> in circulation</a:t>
-            </a:r>
             <a:endParaRPr lang="pt-BR" dirty="0"/>
           </a:p>
         </p:txBody>
@@ -12029,14 +11164,6 @@
           <a:bodyPr/>
           <a:lstStyle/>
           <a:p>
-            <a:r>
-              <a:rPr lang="en-US" dirty="0"/>
-              <a:t>Information disorder refers to the ecosystem of false, misleading, or harmful information</a:t>
-            </a:r>
-            <a:r>
-              <a:rPr lang="pt-BR" dirty="0"/>
-              <a:t> (includes framed content or selective omission)</a:t>
-            </a:r>
             <a:endParaRPr lang="en-US" dirty="0"/>
           </a:p>
         </p:txBody>
@@ -12145,10 +11272,6 @@
           <a:bodyPr/>
           <a:lstStyle/>
           <a:p>
-            <a:r>
-              <a:rPr lang="en-US" dirty="0"/>
-              <a:t>the point isn't to teach misinformation studies, it's to establish that the phenomenon is slippery and contested, which motivates needing better tools than intuition.</a:t>
-            </a:r>
             <a:endParaRPr lang="pt-BR" dirty="0"/>
           </a:p>
         </p:txBody>
@@ -12342,7 +11465,7 @@
           <a:p>
             <a:fld id="{C9B77B62-B9B7-42A1-9B35-726B8340D31A}" type="datetimeFigureOut">
               <a:rPr lang="it-IT" smtClean="0"/>
-              <a:t>23/02/2026</a:t>
+              <a:t>27/02/2026</a:t>
             </a:fld>
             <a:endParaRPr lang="it-IT"/>
           </a:p>
@@ -12540,7 +11663,7 @@
           <a:p>
             <a:fld id="{C9B77B62-B9B7-42A1-9B35-726B8340D31A}" type="datetimeFigureOut">
               <a:rPr lang="it-IT" smtClean="0"/>
-              <a:t>23/02/2026</a:t>
+              <a:t>27/02/2026</a:t>
             </a:fld>
             <a:endParaRPr lang="it-IT"/>
           </a:p>
@@ -12748,7 +11871,7 @@
           <a:p>
             <a:fld id="{C9B77B62-B9B7-42A1-9B35-726B8340D31A}" type="datetimeFigureOut">
               <a:rPr lang="it-IT" smtClean="0"/>
-              <a:t>23/02/2026</a:t>
+              <a:t>27/02/2026</a:t>
             </a:fld>
             <a:endParaRPr lang="it-IT"/>
           </a:p>
@@ -12946,7 +12069,7 @@
           <a:p>
             <a:fld id="{C9B77B62-B9B7-42A1-9B35-726B8340D31A}" type="datetimeFigureOut">
               <a:rPr lang="it-IT" smtClean="0"/>
-              <a:t>23/02/2026</a:t>
+              <a:t>27/02/2026</a:t>
             </a:fld>
             <a:endParaRPr lang="it-IT"/>
           </a:p>
@@ -13221,7 +12344,7 @@
           <a:p>
             <a:fld id="{C9B77B62-B9B7-42A1-9B35-726B8340D31A}" type="datetimeFigureOut">
               <a:rPr lang="it-IT" smtClean="0"/>
-              <a:t>23/02/2026</a:t>
+              <a:t>27/02/2026</a:t>
             </a:fld>
             <a:endParaRPr lang="it-IT"/>
           </a:p>
@@ -13486,7 +12609,7 @@
           <a:p>
             <a:fld id="{C9B77B62-B9B7-42A1-9B35-726B8340D31A}" type="datetimeFigureOut">
               <a:rPr lang="it-IT" smtClean="0"/>
-              <a:t>23/02/2026</a:t>
+              <a:t>27/02/2026</a:t>
             </a:fld>
             <a:endParaRPr lang="it-IT"/>
           </a:p>
@@ -13898,7 +13021,7 @@
           <a:p>
             <a:fld id="{C9B77B62-B9B7-42A1-9B35-726B8340D31A}" type="datetimeFigureOut">
               <a:rPr lang="it-IT" smtClean="0"/>
-              <a:t>23/02/2026</a:t>
+              <a:t>27/02/2026</a:t>
             </a:fld>
             <a:endParaRPr lang="it-IT"/>
           </a:p>
@@ -14039,7 +13162,7 @@
           <a:p>
             <a:fld id="{C9B77B62-B9B7-42A1-9B35-726B8340D31A}" type="datetimeFigureOut">
               <a:rPr lang="it-IT" smtClean="0"/>
-              <a:t>23/02/2026</a:t>
+              <a:t>27/02/2026</a:t>
             </a:fld>
             <a:endParaRPr lang="it-IT"/>
           </a:p>
@@ -14152,7 +13275,7 @@
           <a:p>
             <a:fld id="{C9B77B62-B9B7-42A1-9B35-726B8340D31A}" type="datetimeFigureOut">
               <a:rPr lang="it-IT" smtClean="0"/>
-              <a:t>23/02/2026</a:t>
+              <a:t>27/02/2026</a:t>
             </a:fld>
             <a:endParaRPr lang="it-IT"/>
           </a:p>
@@ -14463,7 +13586,7 @@
           <a:p>
             <a:fld id="{C9B77B62-B9B7-42A1-9B35-726B8340D31A}" type="datetimeFigureOut">
               <a:rPr lang="it-IT" smtClean="0"/>
-              <a:t>23/02/2026</a:t>
+              <a:t>27/02/2026</a:t>
             </a:fld>
             <a:endParaRPr lang="it-IT"/>
           </a:p>
@@ -14751,7 +13874,7 @@
           <a:p>
             <a:fld id="{C9B77B62-B9B7-42A1-9B35-726B8340D31A}" type="datetimeFigureOut">
               <a:rPr lang="it-IT" smtClean="0"/>
-              <a:t>23/02/2026</a:t>
+              <a:t>27/02/2026</a:t>
             </a:fld>
             <a:endParaRPr lang="it-IT"/>
           </a:p>
@@ -14992,7 +14115,7 @@
           <a:p>
             <a:fld id="{C9B77B62-B9B7-42A1-9B35-726B8340D31A}" type="datetimeFigureOut">
               <a:rPr lang="it-IT" smtClean="0"/>
-              <a:t>23/02/2026</a:t>
+              <a:t>27/02/2026</a:t>
             </a:fld>
             <a:endParaRPr lang="it-IT"/>
           </a:p>
@@ -16052,431 +15175,6 @@
 </file>
 
 <file path=ppt/slides/slide11.xml><?xml version="1.0" encoding="utf-8"?>
-<p:sld xmlns:a="http://schemas.openxmlformats.org/drawingml/2006/main" xmlns:r="http://schemas.openxmlformats.org/officeDocument/2006/relationships" xmlns:p="http://schemas.openxmlformats.org/presentationml/2006/main" show="0">
-  <p:cSld>
-    <p:spTree>
-      <p:nvGrpSpPr>
-        <p:cNvPr id="1" name="">
-          <a:extLst>
-            <a:ext uri="{FF2B5EF4-FFF2-40B4-BE49-F238E27FC236}">
-              <a16:creationId xmlns:a16="http://schemas.microsoft.com/office/drawing/2014/main" id="{F9C7047E-358D-5DDE-A402-B187628544E4}"/>
-            </a:ext>
-          </a:extLst>
-        </p:cNvPr>
-        <p:cNvGrpSpPr/>
-        <p:nvPr/>
-      </p:nvGrpSpPr>
-      <p:grpSpPr>
-        <a:xfrm>
-          <a:off x="0" y="0"/>
-          <a:ext cx="0" cy="0"/>
-          <a:chOff x="0" y="0"/>
-          <a:chExt cx="0" cy="0"/>
-        </a:xfrm>
-      </p:grpSpPr>
-      <p:sp>
-        <p:nvSpPr>
-          <p:cNvPr id="2" name="Titolo 1">
-            <a:extLst>
-              <a:ext uri="{FF2B5EF4-FFF2-40B4-BE49-F238E27FC236}">
-                <a16:creationId xmlns:a16="http://schemas.microsoft.com/office/drawing/2014/main" id="{57806174-7905-472A-B3A2-5C4FEC8711AC}"/>
-              </a:ext>
-            </a:extLst>
-          </p:cNvPr>
-          <p:cNvSpPr>
-            <a:spLocks noGrp="1"/>
-          </p:cNvSpPr>
-          <p:nvPr>
-            <p:ph type="title"/>
-          </p:nvPr>
-        </p:nvSpPr>
-        <p:spPr/>
-        <p:txBody>
-          <a:bodyPr/>
-          <a:lstStyle/>
-          <a:p>
-            <a:r>
-              <a:rPr lang="pt-BR" dirty="0"/>
-              <a:t>How does this relate to text?</a:t>
-            </a:r>
-            <a:endParaRPr lang="it-IT" dirty="0"/>
-          </a:p>
-        </p:txBody>
-      </p:sp>
-      <p:sp>
-        <p:nvSpPr>
-          <p:cNvPr id="3" name="Segnaposto contenuto 2">
-            <a:extLst>
-              <a:ext uri="{FF2B5EF4-FFF2-40B4-BE49-F238E27FC236}">
-                <a16:creationId xmlns:a16="http://schemas.microsoft.com/office/drawing/2014/main" id="{C4189781-646E-BECA-896E-6DE019AFFDCE}"/>
-              </a:ext>
-            </a:extLst>
-          </p:cNvPr>
-          <p:cNvSpPr>
-            <a:spLocks noGrp="1"/>
-          </p:cNvSpPr>
-          <p:nvPr>
-            <p:ph idx="1"/>
-          </p:nvPr>
-        </p:nvSpPr>
-        <p:spPr>
-          <a:xfrm>
-            <a:off x="838200" y="1482811"/>
-            <a:ext cx="10515600" cy="5202194"/>
-          </a:xfrm>
-        </p:spPr>
-        <p:txBody>
-          <a:bodyPr>
-            <a:normAutofit fontScale="85000" lnSpcReduction="20000"/>
-          </a:bodyPr>
-          <a:lstStyle/>
-          <a:p>
-            <a:r>
-              <a:rPr lang="pt-BR" dirty="0"/>
-              <a:t>Rethorical features can trigger and exploit cognitive biases</a:t>
-            </a:r>
-            <a:endParaRPr lang="it-IT" dirty="0"/>
-          </a:p>
-          <a:p>
-            <a:r>
-              <a:rPr lang="it-IT" dirty="0"/>
-              <a:t>Some </a:t>
-            </a:r>
-            <a:r>
-              <a:rPr lang="it-IT" dirty="0" err="1"/>
-              <a:t>examples</a:t>
-            </a:r>
-            <a:r>
-              <a:rPr lang="it-IT" dirty="0"/>
-              <a:t>:</a:t>
-            </a:r>
-          </a:p>
-          <a:p>
-            <a:pPr lvl="1"/>
-            <a:r>
-              <a:rPr lang="it-IT" dirty="0" err="1"/>
-              <a:t>Ambiguity</a:t>
-            </a:r>
-            <a:r>
-              <a:rPr lang="it-IT" dirty="0"/>
-              <a:t> («Reports </a:t>
-            </a:r>
-            <a:r>
-              <a:rPr lang="it-IT" dirty="0" err="1"/>
-              <a:t>suggest</a:t>
-            </a:r>
-            <a:r>
-              <a:rPr lang="it-IT" dirty="0"/>
-              <a:t>…»)</a:t>
-            </a:r>
-          </a:p>
-          <a:p>
-            <a:pPr lvl="1"/>
-            <a:r>
-              <a:rPr lang="it-IT" dirty="0" err="1"/>
-              <a:t>Repetition</a:t>
-            </a:r>
-            <a:endParaRPr lang="it-IT" dirty="0"/>
-          </a:p>
-          <a:p>
-            <a:pPr lvl="1"/>
-            <a:r>
-              <a:rPr lang="it-IT" dirty="0" err="1"/>
-              <a:t>Emotional</a:t>
-            </a:r>
-            <a:r>
-              <a:rPr lang="it-IT" dirty="0"/>
-              <a:t> </a:t>
-            </a:r>
-            <a:r>
-              <a:rPr lang="it-IT" dirty="0" err="1"/>
-              <a:t>valence</a:t>
-            </a:r>
-            <a:r>
-              <a:rPr lang="it-IT" dirty="0"/>
-              <a:t> («</a:t>
-            </a:r>
-            <a:r>
-              <a:rPr lang="it-IT" dirty="0" err="1"/>
-              <a:t>Catastrophic</a:t>
-            </a:r>
-            <a:r>
-              <a:rPr lang="it-IT" dirty="0"/>
-              <a:t> </a:t>
-            </a:r>
-            <a:r>
-              <a:rPr lang="it-IT" dirty="0" err="1"/>
-              <a:t>threat</a:t>
-            </a:r>
-            <a:r>
-              <a:rPr lang="it-IT" dirty="0"/>
-              <a:t>…»)</a:t>
-            </a:r>
-          </a:p>
-          <a:p>
-            <a:pPr lvl="1"/>
-            <a:r>
-              <a:rPr lang="it-IT" dirty="0" err="1"/>
-              <a:t>Dehumanization</a:t>
-            </a:r>
-            <a:r>
-              <a:rPr lang="it-IT" dirty="0"/>
-              <a:t> («</a:t>
-            </a:r>
-            <a:r>
-              <a:rPr lang="it-IT" dirty="0" err="1"/>
-              <a:t>Illegal</a:t>
-            </a:r>
-            <a:r>
-              <a:rPr lang="it-IT" dirty="0"/>
-              <a:t> </a:t>
-            </a:r>
-            <a:r>
-              <a:rPr lang="it-IT" dirty="0" err="1"/>
-              <a:t>aliens</a:t>
-            </a:r>
-            <a:r>
-              <a:rPr lang="it-IT" dirty="0"/>
-              <a:t>»)</a:t>
-            </a:r>
-          </a:p>
-          <a:p>
-            <a:pPr lvl="1"/>
-            <a:r>
-              <a:rPr lang="it-IT" dirty="0" err="1"/>
-              <a:t>Intensifiers</a:t>
-            </a:r>
-            <a:r>
-              <a:rPr lang="it-IT" dirty="0"/>
-              <a:t> («</a:t>
-            </a:r>
-            <a:r>
-              <a:rPr lang="it-IT" dirty="0" err="1"/>
-              <a:t>Unprecedented</a:t>
-            </a:r>
-            <a:r>
-              <a:rPr lang="it-IT" dirty="0"/>
-              <a:t> </a:t>
-            </a:r>
-            <a:r>
-              <a:rPr lang="it-IT" dirty="0" err="1"/>
-              <a:t>crisis</a:t>
-            </a:r>
-            <a:r>
-              <a:rPr lang="it-IT" dirty="0"/>
-              <a:t>…»; «</a:t>
-            </a:r>
-            <a:r>
-              <a:rPr lang="it-IT" dirty="0" err="1"/>
-              <a:t>Thousands</a:t>
-            </a:r>
-            <a:r>
-              <a:rPr lang="it-IT" dirty="0"/>
-              <a:t> </a:t>
-            </a:r>
-            <a:r>
-              <a:rPr lang="it-IT" dirty="0" err="1"/>
-              <a:t>affected</a:t>
-            </a:r>
-            <a:r>
-              <a:rPr lang="it-IT" dirty="0"/>
-              <a:t>»)</a:t>
-            </a:r>
-          </a:p>
-          <a:p>
-            <a:pPr lvl="1"/>
-            <a:r>
-              <a:rPr lang="it-IT" dirty="0"/>
-              <a:t>Narrative framing (e.g., </a:t>
-            </a:r>
-            <a:r>
-              <a:rPr lang="it-IT" dirty="0" err="1"/>
-              <a:t>victimhood</a:t>
-            </a:r>
-            <a:r>
-              <a:rPr lang="it-IT" dirty="0"/>
-              <a:t>)</a:t>
-            </a:r>
-          </a:p>
-          <a:p>
-            <a:pPr lvl="1"/>
-            <a:r>
-              <a:rPr lang="it-IT" dirty="0"/>
-              <a:t>Social </a:t>
-            </a:r>
-            <a:r>
-              <a:rPr lang="it-IT" dirty="0" err="1"/>
-              <a:t>proofing</a:t>
-            </a:r>
-            <a:r>
-              <a:rPr lang="it-IT" dirty="0"/>
-              <a:t> («</a:t>
-            </a:r>
-            <a:r>
-              <a:rPr lang="it-IT" dirty="0" err="1"/>
-              <a:t>Many</a:t>
-            </a:r>
-            <a:r>
-              <a:rPr lang="it-IT" dirty="0"/>
-              <a:t> </a:t>
-            </a:r>
-            <a:r>
-              <a:rPr lang="it-IT" dirty="0" err="1"/>
-              <a:t>believe</a:t>
-            </a:r>
-            <a:r>
-              <a:rPr lang="it-IT" dirty="0"/>
-              <a:t>…»)</a:t>
-            </a:r>
-          </a:p>
-          <a:p>
-            <a:pPr lvl="1"/>
-            <a:r>
-              <a:rPr lang="it-IT" dirty="0"/>
-              <a:t>Authority appeals («Scientists </a:t>
-            </a:r>
-            <a:r>
-              <a:rPr lang="it-IT" dirty="0" err="1"/>
-              <a:t>confirm</a:t>
-            </a:r>
-            <a:r>
-              <a:rPr lang="it-IT" dirty="0"/>
-              <a:t>…»)</a:t>
-            </a:r>
-          </a:p>
-          <a:p>
-            <a:pPr lvl="1"/>
-            <a:r>
-              <a:rPr lang="it-IT" dirty="0" err="1"/>
-              <a:t>Pseudo-scientific</a:t>
-            </a:r>
-            <a:r>
-              <a:rPr lang="it-IT" dirty="0"/>
-              <a:t> </a:t>
-            </a:r>
-            <a:r>
-              <a:rPr lang="it-IT" dirty="0" err="1"/>
-              <a:t>language</a:t>
-            </a:r>
-            <a:endParaRPr lang="it-IT" dirty="0"/>
-          </a:p>
-          <a:p>
-            <a:pPr lvl="1"/>
-            <a:r>
-              <a:rPr lang="it-IT" dirty="0" err="1"/>
-              <a:t>Epistemic</a:t>
-            </a:r>
-            <a:r>
-              <a:rPr lang="it-IT" dirty="0"/>
-              <a:t> markers («</a:t>
-            </a:r>
-            <a:r>
-              <a:rPr lang="it-IT" dirty="0" err="1"/>
-              <a:t>There</a:t>
-            </a:r>
-            <a:r>
-              <a:rPr lang="it-IT" dirty="0"/>
-              <a:t> </a:t>
-            </a:r>
-            <a:r>
-              <a:rPr lang="it-IT" dirty="0" err="1"/>
-              <a:t>is</a:t>
-            </a:r>
-            <a:r>
-              <a:rPr lang="it-IT" dirty="0"/>
-              <a:t> no </a:t>
-            </a:r>
-            <a:r>
-              <a:rPr lang="it-IT" dirty="0" err="1"/>
-              <a:t>doubt</a:t>
-            </a:r>
-            <a:r>
-              <a:rPr lang="it-IT" dirty="0"/>
-              <a:t> </a:t>
-            </a:r>
-            <a:r>
-              <a:rPr lang="it-IT" dirty="0" err="1"/>
-              <a:t>that</a:t>
-            </a:r>
-            <a:r>
-              <a:rPr lang="it-IT" dirty="0"/>
-              <a:t>»)</a:t>
-            </a:r>
-          </a:p>
-          <a:p>
-            <a:pPr lvl="1"/>
-            <a:r>
-              <a:rPr lang="it-IT" dirty="0"/>
-              <a:t>Shorter words</a:t>
-            </a:r>
-          </a:p>
-          <a:p>
-            <a:pPr lvl="1"/>
-            <a:r>
-              <a:rPr lang="it-IT" dirty="0" err="1"/>
-              <a:t>Us</a:t>
-            </a:r>
-            <a:r>
-              <a:rPr lang="it-IT" dirty="0"/>
-              <a:t> vs. </a:t>
-            </a:r>
-            <a:r>
-              <a:rPr lang="it-IT" dirty="0" err="1"/>
-              <a:t>Them</a:t>
-            </a:r>
-            <a:endParaRPr lang="it-IT" dirty="0"/>
-          </a:p>
-          <a:p>
-            <a:pPr lvl="1"/>
-            <a:r>
-              <a:rPr lang="it-IT" dirty="0" err="1"/>
-              <a:t>Moralization</a:t>
-            </a:r>
-            <a:endParaRPr lang="it-IT" dirty="0"/>
-          </a:p>
-          <a:p>
-            <a:pPr lvl="1"/>
-            <a:r>
-              <a:rPr lang="it-IT" dirty="0" err="1"/>
-              <a:t>Rethorical</a:t>
-            </a:r>
-            <a:r>
-              <a:rPr lang="it-IT" dirty="0"/>
-              <a:t> </a:t>
-            </a:r>
-            <a:r>
-              <a:rPr lang="it-IT" dirty="0" err="1"/>
-              <a:t>questions</a:t>
-            </a:r>
-            <a:endParaRPr lang="it-IT" dirty="0"/>
-          </a:p>
-          <a:p>
-            <a:pPr lvl="1"/>
-            <a:r>
-              <a:rPr lang="it-IT" dirty="0" err="1"/>
-              <a:t>Anecdotal</a:t>
-            </a:r>
-            <a:r>
-              <a:rPr lang="it-IT" dirty="0"/>
-              <a:t> reporting </a:t>
-            </a:r>
-          </a:p>
-        </p:txBody>
-      </p:sp>
-    </p:spTree>
-    <p:extLst>
-      <p:ext uri="{BB962C8B-B14F-4D97-AF65-F5344CB8AC3E}">
-        <p14:creationId xmlns:p14="http://schemas.microsoft.com/office/powerpoint/2010/main" val="2257325946"/>
-      </p:ext>
-    </p:extLst>
-  </p:cSld>
-  <p:clrMapOvr>
-    <a:masterClrMapping/>
-  </p:clrMapOvr>
-</p:sld>
-</file>
-
-<file path=ppt/slides/slide12.xml><?xml version="1.0" encoding="utf-8"?>
 <p:sld xmlns:a="http://schemas.openxmlformats.org/drawingml/2006/main" xmlns:r="http://schemas.openxmlformats.org/officeDocument/2006/relationships" xmlns:p="http://schemas.openxmlformats.org/presentationml/2006/main">
   <p:cSld>
     <p:spTree>
@@ -16935,7 +15633,7 @@
 </p:sld>
 </file>
 
-<file path=ppt/slides/slide13.xml><?xml version="1.0" encoding="utf-8"?>
+<file path=ppt/slides/slide12.xml><?xml version="1.0" encoding="utf-8"?>
 <p:sld xmlns:a="http://schemas.openxmlformats.org/drawingml/2006/main" xmlns:r="http://schemas.openxmlformats.org/officeDocument/2006/relationships" xmlns:p="http://schemas.openxmlformats.org/presentationml/2006/main">
   <p:cSld>
     <p:spTree>
@@ -17458,7 +16156,7 @@
 </p:sld>
 </file>
 
-<file path=ppt/slides/slide14.xml><?xml version="1.0" encoding="utf-8"?>
+<file path=ppt/slides/slide13.xml><?xml version="1.0" encoding="utf-8"?>
 <p:sld xmlns:a="http://schemas.openxmlformats.org/drawingml/2006/main" xmlns:r="http://schemas.openxmlformats.org/officeDocument/2006/relationships" xmlns:p="http://schemas.openxmlformats.org/presentationml/2006/main">
   <p:cSld>
     <p:spTree>
@@ -17971,7 +16669,7 @@
 </p:sld>
 </file>
 
-<file path=ppt/slides/slide15.xml><?xml version="1.0" encoding="utf-8"?>
+<file path=ppt/slides/slide14.xml><?xml version="1.0" encoding="utf-8"?>
 <p:sld xmlns:a="http://schemas.openxmlformats.org/drawingml/2006/main" xmlns:r="http://schemas.openxmlformats.org/officeDocument/2006/relationships" xmlns:p="http://schemas.openxmlformats.org/presentationml/2006/main">
   <p:cSld>
     <p:spTree>
@@ -18460,7 +17158,7 @@
 </p:sld>
 </file>
 
-<file path=ppt/slides/slide16.xml><?xml version="1.0" encoding="utf-8"?>
+<file path=ppt/slides/slide15.xml><?xml version="1.0" encoding="utf-8"?>
 <p:sld xmlns:a="http://schemas.openxmlformats.org/drawingml/2006/main" xmlns:r="http://schemas.openxmlformats.org/officeDocument/2006/relationships" xmlns:p="http://schemas.openxmlformats.org/presentationml/2006/main">
   <p:cSld>
     <p:spTree>
@@ -18850,7 +17548,7 @@
 </p:sld>
 </file>
 
-<file path=ppt/slides/slide17.xml><?xml version="1.0" encoding="utf-8"?>
+<file path=ppt/slides/slide16.xml><?xml version="1.0" encoding="utf-8"?>
 <p:sld xmlns:a="http://schemas.openxmlformats.org/drawingml/2006/main" xmlns:r="http://schemas.openxmlformats.org/officeDocument/2006/relationships" xmlns:p="http://schemas.openxmlformats.org/presentationml/2006/main">
   <p:cSld>
     <p:spTree>
@@ -19618,7 +18316,7 @@
 </p:sld>
 </file>
 
-<file path=ppt/slides/slide18.xml><?xml version="1.0" encoding="utf-8"?>
+<file path=ppt/slides/slide17.xml><?xml version="1.0" encoding="utf-8"?>
 <p:sld xmlns:a="http://schemas.openxmlformats.org/drawingml/2006/main" xmlns:r="http://schemas.openxmlformats.org/officeDocument/2006/relationships" xmlns:p="http://schemas.openxmlformats.org/presentationml/2006/main">
   <p:cSld>
     <p:spTree>
@@ -20058,1269 +18756,7 @@
 </p:sld>
 </file>
 
-<file path=ppt/slides/slide19.xml><?xml version="1.0" encoding="utf-8"?>
-<p:sld xmlns:a="http://schemas.openxmlformats.org/drawingml/2006/main" xmlns:r="http://schemas.openxmlformats.org/officeDocument/2006/relationships" xmlns:p="http://schemas.openxmlformats.org/presentationml/2006/main" show="0">
-  <p:cSld>
-    <p:spTree>
-      <p:nvGrpSpPr>
-        <p:cNvPr id="1" name=""/>
-        <p:cNvGrpSpPr/>
-        <p:nvPr/>
-      </p:nvGrpSpPr>
-      <p:grpSpPr>
-        <a:xfrm>
-          <a:off x="0" y="0"/>
-          <a:ext cx="0" cy="0"/>
-          <a:chOff x="0" y="0"/>
-          <a:chExt cx="0" cy="0"/>
-        </a:xfrm>
-      </p:grpSpPr>
-      <p:sp>
-        <p:nvSpPr>
-          <p:cNvPr id="2" name="Titolo 1">
-            <a:extLst>
-              <a:ext uri="{FF2B5EF4-FFF2-40B4-BE49-F238E27FC236}">
-                <a16:creationId xmlns:a16="http://schemas.microsoft.com/office/drawing/2014/main" id="{D1323575-F3E6-C42A-D1E4-9E1A25914DF2}"/>
-              </a:ext>
-            </a:extLst>
-          </p:cNvPr>
-          <p:cNvSpPr>
-            <a:spLocks noGrp="1"/>
-          </p:cNvSpPr>
-          <p:nvPr>
-            <p:ph type="title"/>
-          </p:nvPr>
-        </p:nvSpPr>
-        <p:spPr/>
-        <p:txBody>
-          <a:bodyPr/>
-          <a:lstStyle/>
-          <a:p>
-            <a:r>
-              <a:rPr lang="pt-BR" dirty="0"/>
-              <a:t>The limits of debunking</a:t>
-            </a:r>
-            <a:endParaRPr lang="it-IT" dirty="0"/>
-          </a:p>
-        </p:txBody>
-      </p:sp>
-      <p:sp>
-        <p:nvSpPr>
-          <p:cNvPr id="3" name="Segnaposto contenuto 2">
-            <a:extLst>
-              <a:ext uri="{FF2B5EF4-FFF2-40B4-BE49-F238E27FC236}">
-                <a16:creationId xmlns:a16="http://schemas.microsoft.com/office/drawing/2014/main" id="{F96E166F-86EF-F5FC-2995-4995470450A7}"/>
-              </a:ext>
-            </a:extLst>
-          </p:cNvPr>
-          <p:cNvSpPr>
-            <a:spLocks noGrp="1"/>
-          </p:cNvSpPr>
-          <p:nvPr>
-            <p:ph idx="1"/>
-          </p:nvPr>
-        </p:nvSpPr>
-        <p:spPr>
-          <a:xfrm>
-            <a:off x="838200" y="1825624"/>
-            <a:ext cx="10515600" cy="4871737"/>
-          </a:xfrm>
-        </p:spPr>
-        <p:txBody>
-          <a:bodyPr>
-            <a:normAutofit lnSpcReduction="10000"/>
-          </a:bodyPr>
-          <a:lstStyle/>
-          <a:p>
-            <a:r>
-              <a:rPr lang="pt-BR" dirty="0"/>
-              <a:t>Prebunking vs debunking </a:t>
-            </a:r>
-            <a:r>
-              <a:rPr lang="pt-BR" baseline="30000" dirty="0"/>
-              <a:t>[15]</a:t>
-            </a:r>
-          </a:p>
-          <a:p>
-            <a:r>
-              <a:rPr lang="pt-BR" dirty="0"/>
-              <a:t>Examples:</a:t>
-            </a:r>
-          </a:p>
-          <a:p>
-            <a:pPr lvl="1"/>
-            <a:r>
-              <a:rPr lang="pt-BR" dirty="0"/>
-              <a:t>Inoculation, </a:t>
-            </a:r>
-            <a:r>
-              <a:rPr lang="pt-BR" u="sng" dirty="0"/>
-              <a:t>accuracy</a:t>
-            </a:r>
-            <a:r>
-              <a:rPr lang="pt-BR" dirty="0"/>
-              <a:t> nudges, media literacy</a:t>
-            </a:r>
-          </a:p>
-          <a:p>
-            <a:pPr lvl="1"/>
-            <a:r>
-              <a:rPr lang="pt-BR" dirty="0"/>
-              <a:t>Fact-checking corrections, platform labels</a:t>
-            </a:r>
-          </a:p>
-          <a:p>
-            <a:r>
-              <a:rPr lang="pt-BR" dirty="0"/>
-              <a:t>Classifiers are closer to debunking than prebunking</a:t>
-            </a:r>
-          </a:p>
-          <a:p>
-            <a:r>
-              <a:rPr lang="pt-BR" dirty="0"/>
-              <a:t>Prebunking &gt; debunking ?</a:t>
-            </a:r>
-          </a:p>
-          <a:p>
-            <a:r>
-              <a:rPr lang="pt-BR" dirty="0"/>
-              <a:t>Debunking works too but:</a:t>
-            </a:r>
-          </a:p>
-          <a:p>
-            <a:pPr lvl="1"/>
-            <a:r>
-              <a:rPr lang="pt-BR" dirty="0"/>
-              <a:t>Causal alternative &gt; retraction</a:t>
-            </a:r>
-          </a:p>
-          <a:p>
-            <a:pPr lvl="1"/>
-            <a:r>
-              <a:rPr lang="pt-BR" dirty="0"/>
-              <a:t>Correction from high-credibility sources</a:t>
-            </a:r>
-          </a:p>
-          <a:p>
-            <a:pPr lvl="1"/>
-            <a:r>
-              <a:rPr lang="pt-BR" dirty="0"/>
-              <a:t>Language is important</a:t>
-            </a:r>
-          </a:p>
-          <a:p>
-            <a:pPr lvl="1"/>
-            <a:r>
-              <a:rPr lang="pt-BR" dirty="0"/>
-              <a:t>Effects do not last/generalize to group-level</a:t>
-            </a:r>
-          </a:p>
-          <a:p>
-            <a:pPr lvl="1"/>
-            <a:endParaRPr lang="pt-BR" dirty="0"/>
-          </a:p>
-          <a:p>
-            <a:pPr lvl="1"/>
-            <a:endParaRPr lang="pt-BR" dirty="0"/>
-          </a:p>
-          <a:p>
-            <a:endParaRPr lang="pt-BR" dirty="0"/>
-          </a:p>
-          <a:p>
-            <a:endParaRPr lang="it-IT" dirty="0"/>
-          </a:p>
-        </p:txBody>
-      </p:sp>
-    </p:spTree>
-    <p:extLst>
-      <p:ext uri="{BB962C8B-B14F-4D97-AF65-F5344CB8AC3E}">
-        <p14:creationId xmlns:p14="http://schemas.microsoft.com/office/powerpoint/2010/main" val="4241700792"/>
-      </p:ext>
-    </p:extLst>
-  </p:cSld>
-  <p:clrMapOvr>
-    <a:masterClrMapping/>
-  </p:clrMapOvr>
-  <p:timing>
-    <p:tnLst>
-      <p:par>
-        <p:cTn id="1" dur="indefinite" restart="never" nodeType="tmRoot">
-          <p:childTnLst>
-            <p:seq concurrent="1" nextAc="seek">
-              <p:cTn id="2" dur="indefinite" nodeType="mainSeq">
-                <p:childTnLst>
-                  <p:par>
-                    <p:cTn id="3" fill="hold">
-                      <p:stCondLst>
-                        <p:cond delay="indefinite"/>
-                      </p:stCondLst>
-                      <p:childTnLst>
-                        <p:par>
-                          <p:cTn id="4" fill="hold">
-                            <p:stCondLst>
-                              <p:cond delay="0"/>
-                            </p:stCondLst>
-                            <p:childTnLst>
-                              <p:par>
-                                <p:cTn id="5" presetID="1" presetClass="entr" presetSubtype="0" fill="hold" grpId="0" nodeType="clickEffect">
-                                  <p:stCondLst>
-                                    <p:cond delay="0"/>
-                                  </p:stCondLst>
-                                  <p:childTnLst>
-                                    <p:set>
-                                      <p:cBhvr>
-                                        <p:cTn id="6" dur="1" fill="hold">
-                                          <p:stCondLst>
-                                            <p:cond delay="0"/>
-                                          </p:stCondLst>
-                                        </p:cTn>
-                                        <p:tgtEl>
-                                          <p:spTgt spid="3">
-                                            <p:txEl>
-                                              <p:pRg st="0" end="0"/>
-                                            </p:txEl>
-                                          </p:spTgt>
-                                        </p:tgtEl>
-                                        <p:attrNameLst>
-                                          <p:attrName>style.visibility</p:attrName>
-                                        </p:attrNameLst>
-                                      </p:cBhvr>
-                                      <p:to>
-                                        <p:strVal val="visible"/>
-                                      </p:to>
-                                    </p:set>
-                                  </p:childTnLst>
-                                </p:cTn>
-                              </p:par>
-                            </p:childTnLst>
-                          </p:cTn>
-                        </p:par>
-                      </p:childTnLst>
-                    </p:cTn>
-                  </p:par>
-                  <p:par>
-                    <p:cTn id="7" fill="hold">
-                      <p:stCondLst>
-                        <p:cond delay="indefinite"/>
-                      </p:stCondLst>
-                      <p:childTnLst>
-                        <p:par>
-                          <p:cTn id="8" fill="hold">
-                            <p:stCondLst>
-                              <p:cond delay="0"/>
-                            </p:stCondLst>
-                            <p:childTnLst>
-                              <p:par>
-                                <p:cTn id="9" presetID="1" presetClass="entr" presetSubtype="0" fill="hold" grpId="0" nodeType="clickEffect">
-                                  <p:stCondLst>
-                                    <p:cond delay="0"/>
-                                  </p:stCondLst>
-                                  <p:childTnLst>
-                                    <p:set>
-                                      <p:cBhvr>
-                                        <p:cTn id="10" dur="1" fill="hold">
-                                          <p:stCondLst>
-                                            <p:cond delay="0"/>
-                                          </p:stCondLst>
-                                        </p:cTn>
-                                        <p:tgtEl>
-                                          <p:spTgt spid="3">
-                                            <p:txEl>
-                                              <p:pRg st="1" end="1"/>
-                                            </p:txEl>
-                                          </p:spTgt>
-                                        </p:tgtEl>
-                                        <p:attrNameLst>
-                                          <p:attrName>style.visibility</p:attrName>
-                                        </p:attrNameLst>
-                                      </p:cBhvr>
-                                      <p:to>
-                                        <p:strVal val="visible"/>
-                                      </p:to>
-                                    </p:set>
-                                  </p:childTnLst>
-                                </p:cTn>
-                              </p:par>
-                              <p:par>
-                                <p:cTn id="11" presetID="1" presetClass="entr" presetSubtype="0" fill="hold" grpId="0" nodeType="withEffect">
-                                  <p:stCondLst>
-                                    <p:cond delay="0"/>
-                                  </p:stCondLst>
-                                  <p:childTnLst>
-                                    <p:set>
-                                      <p:cBhvr>
-                                        <p:cTn id="12" dur="1" fill="hold">
-                                          <p:stCondLst>
-                                            <p:cond delay="0"/>
-                                          </p:stCondLst>
-                                        </p:cTn>
-                                        <p:tgtEl>
-                                          <p:spTgt spid="3">
-                                            <p:txEl>
-                                              <p:pRg st="2" end="2"/>
-                                            </p:txEl>
-                                          </p:spTgt>
-                                        </p:tgtEl>
-                                        <p:attrNameLst>
-                                          <p:attrName>style.visibility</p:attrName>
-                                        </p:attrNameLst>
-                                      </p:cBhvr>
-                                      <p:to>
-                                        <p:strVal val="visible"/>
-                                      </p:to>
-                                    </p:set>
-                                  </p:childTnLst>
-                                </p:cTn>
-                              </p:par>
-                              <p:par>
-                                <p:cTn id="13" presetID="1" presetClass="entr" presetSubtype="0" fill="hold" grpId="0" nodeType="withEffect">
-                                  <p:stCondLst>
-                                    <p:cond delay="0"/>
-                                  </p:stCondLst>
-                                  <p:childTnLst>
-                                    <p:set>
-                                      <p:cBhvr>
-                                        <p:cTn id="14" dur="1" fill="hold">
-                                          <p:stCondLst>
-                                            <p:cond delay="0"/>
-                                          </p:stCondLst>
-                                        </p:cTn>
-                                        <p:tgtEl>
-                                          <p:spTgt spid="3">
-                                            <p:txEl>
-                                              <p:pRg st="3" end="3"/>
-                                            </p:txEl>
-                                          </p:spTgt>
-                                        </p:tgtEl>
-                                        <p:attrNameLst>
-                                          <p:attrName>style.visibility</p:attrName>
-                                        </p:attrNameLst>
-                                      </p:cBhvr>
-                                      <p:to>
-                                        <p:strVal val="visible"/>
-                                      </p:to>
-                                    </p:set>
-                                  </p:childTnLst>
-                                </p:cTn>
-                              </p:par>
-                            </p:childTnLst>
-                          </p:cTn>
-                        </p:par>
-                      </p:childTnLst>
-                    </p:cTn>
-                  </p:par>
-                  <p:par>
-                    <p:cTn id="15" fill="hold">
-                      <p:stCondLst>
-                        <p:cond delay="indefinite"/>
-                      </p:stCondLst>
-                      <p:childTnLst>
-                        <p:par>
-                          <p:cTn id="16" fill="hold">
-                            <p:stCondLst>
-                              <p:cond delay="0"/>
-                            </p:stCondLst>
-                            <p:childTnLst>
-                              <p:par>
-                                <p:cTn id="17" presetID="1" presetClass="entr" presetSubtype="0" fill="hold" grpId="0" nodeType="clickEffect">
-                                  <p:stCondLst>
-                                    <p:cond delay="0"/>
-                                  </p:stCondLst>
-                                  <p:childTnLst>
-                                    <p:set>
-                                      <p:cBhvr>
-                                        <p:cTn id="18" dur="1" fill="hold">
-                                          <p:stCondLst>
-                                            <p:cond delay="0"/>
-                                          </p:stCondLst>
-                                        </p:cTn>
-                                        <p:tgtEl>
-                                          <p:spTgt spid="3">
-                                            <p:txEl>
-                                              <p:pRg st="4" end="4"/>
-                                            </p:txEl>
-                                          </p:spTgt>
-                                        </p:tgtEl>
-                                        <p:attrNameLst>
-                                          <p:attrName>style.visibility</p:attrName>
-                                        </p:attrNameLst>
-                                      </p:cBhvr>
-                                      <p:to>
-                                        <p:strVal val="visible"/>
-                                      </p:to>
-                                    </p:set>
-                                  </p:childTnLst>
-                                </p:cTn>
-                              </p:par>
-                            </p:childTnLst>
-                          </p:cTn>
-                        </p:par>
-                      </p:childTnLst>
-                    </p:cTn>
-                  </p:par>
-                  <p:par>
-                    <p:cTn id="19" fill="hold">
-                      <p:stCondLst>
-                        <p:cond delay="indefinite"/>
-                      </p:stCondLst>
-                      <p:childTnLst>
-                        <p:par>
-                          <p:cTn id="20" fill="hold">
-                            <p:stCondLst>
-                              <p:cond delay="0"/>
-                            </p:stCondLst>
-                            <p:childTnLst>
-                              <p:par>
-                                <p:cTn id="21" presetID="1" presetClass="entr" presetSubtype="0" fill="hold" grpId="0" nodeType="clickEffect">
-                                  <p:stCondLst>
-                                    <p:cond delay="0"/>
-                                  </p:stCondLst>
-                                  <p:childTnLst>
-                                    <p:set>
-                                      <p:cBhvr>
-                                        <p:cTn id="22" dur="1" fill="hold">
-                                          <p:stCondLst>
-                                            <p:cond delay="0"/>
-                                          </p:stCondLst>
-                                        </p:cTn>
-                                        <p:tgtEl>
-                                          <p:spTgt spid="3">
-                                            <p:txEl>
-                                              <p:pRg st="5" end="5"/>
-                                            </p:txEl>
-                                          </p:spTgt>
-                                        </p:tgtEl>
-                                        <p:attrNameLst>
-                                          <p:attrName>style.visibility</p:attrName>
-                                        </p:attrNameLst>
-                                      </p:cBhvr>
-                                      <p:to>
-                                        <p:strVal val="visible"/>
-                                      </p:to>
-                                    </p:set>
-                                  </p:childTnLst>
-                                </p:cTn>
-                              </p:par>
-                            </p:childTnLst>
-                          </p:cTn>
-                        </p:par>
-                      </p:childTnLst>
-                    </p:cTn>
-                  </p:par>
-                  <p:par>
-                    <p:cTn id="23" fill="hold">
-                      <p:stCondLst>
-                        <p:cond delay="indefinite"/>
-                      </p:stCondLst>
-                      <p:childTnLst>
-                        <p:par>
-                          <p:cTn id="24" fill="hold">
-                            <p:stCondLst>
-                              <p:cond delay="0"/>
-                            </p:stCondLst>
-                            <p:childTnLst>
-                              <p:par>
-                                <p:cTn id="25" presetID="1" presetClass="entr" presetSubtype="0" fill="hold" grpId="0" nodeType="clickEffect">
-                                  <p:stCondLst>
-                                    <p:cond delay="0"/>
-                                  </p:stCondLst>
-                                  <p:childTnLst>
-                                    <p:set>
-                                      <p:cBhvr>
-                                        <p:cTn id="26" dur="1" fill="hold">
-                                          <p:stCondLst>
-                                            <p:cond delay="0"/>
-                                          </p:stCondLst>
-                                        </p:cTn>
-                                        <p:tgtEl>
-                                          <p:spTgt spid="3">
-                                            <p:txEl>
-                                              <p:pRg st="6" end="6"/>
-                                            </p:txEl>
-                                          </p:spTgt>
-                                        </p:tgtEl>
-                                        <p:attrNameLst>
-                                          <p:attrName>style.visibility</p:attrName>
-                                        </p:attrNameLst>
-                                      </p:cBhvr>
-                                      <p:to>
-                                        <p:strVal val="visible"/>
-                                      </p:to>
-                                    </p:set>
-                                  </p:childTnLst>
-                                </p:cTn>
-                              </p:par>
-                              <p:par>
-                                <p:cTn id="27" presetID="1" presetClass="entr" presetSubtype="0" fill="hold" grpId="0" nodeType="withEffect">
-                                  <p:stCondLst>
-                                    <p:cond delay="0"/>
-                                  </p:stCondLst>
-                                  <p:childTnLst>
-                                    <p:set>
-                                      <p:cBhvr>
-                                        <p:cTn id="28" dur="1" fill="hold">
-                                          <p:stCondLst>
-                                            <p:cond delay="0"/>
-                                          </p:stCondLst>
-                                        </p:cTn>
-                                        <p:tgtEl>
-                                          <p:spTgt spid="3">
-                                            <p:txEl>
-                                              <p:pRg st="7" end="7"/>
-                                            </p:txEl>
-                                          </p:spTgt>
-                                        </p:tgtEl>
-                                        <p:attrNameLst>
-                                          <p:attrName>style.visibility</p:attrName>
-                                        </p:attrNameLst>
-                                      </p:cBhvr>
-                                      <p:to>
-                                        <p:strVal val="visible"/>
-                                      </p:to>
-                                    </p:set>
-                                  </p:childTnLst>
-                                </p:cTn>
-                              </p:par>
-                              <p:par>
-                                <p:cTn id="29" presetID="1" presetClass="entr" presetSubtype="0" fill="hold" grpId="0" nodeType="withEffect">
-                                  <p:stCondLst>
-                                    <p:cond delay="0"/>
-                                  </p:stCondLst>
-                                  <p:childTnLst>
-                                    <p:set>
-                                      <p:cBhvr>
-                                        <p:cTn id="30" dur="1" fill="hold">
-                                          <p:stCondLst>
-                                            <p:cond delay="0"/>
-                                          </p:stCondLst>
-                                        </p:cTn>
-                                        <p:tgtEl>
-                                          <p:spTgt spid="3">
-                                            <p:txEl>
-                                              <p:pRg st="8" end="8"/>
-                                            </p:txEl>
-                                          </p:spTgt>
-                                        </p:tgtEl>
-                                        <p:attrNameLst>
-                                          <p:attrName>style.visibility</p:attrName>
-                                        </p:attrNameLst>
-                                      </p:cBhvr>
-                                      <p:to>
-                                        <p:strVal val="visible"/>
-                                      </p:to>
-                                    </p:set>
-                                  </p:childTnLst>
-                                </p:cTn>
-                              </p:par>
-                              <p:par>
-                                <p:cTn id="31" presetID="1" presetClass="entr" presetSubtype="0" fill="hold" grpId="0" nodeType="withEffect">
-                                  <p:stCondLst>
-                                    <p:cond delay="0"/>
-                                  </p:stCondLst>
-                                  <p:childTnLst>
-                                    <p:set>
-                                      <p:cBhvr>
-                                        <p:cTn id="32" dur="1" fill="hold">
-                                          <p:stCondLst>
-                                            <p:cond delay="0"/>
-                                          </p:stCondLst>
-                                        </p:cTn>
-                                        <p:tgtEl>
-                                          <p:spTgt spid="3">
-                                            <p:txEl>
-                                              <p:pRg st="9" end="9"/>
-                                            </p:txEl>
-                                          </p:spTgt>
-                                        </p:tgtEl>
-                                        <p:attrNameLst>
-                                          <p:attrName>style.visibility</p:attrName>
-                                        </p:attrNameLst>
-                                      </p:cBhvr>
-                                      <p:to>
-                                        <p:strVal val="visible"/>
-                                      </p:to>
-                                    </p:set>
-                                  </p:childTnLst>
-                                </p:cTn>
-                              </p:par>
-                              <p:par>
-                                <p:cTn id="33" presetID="1" presetClass="entr" presetSubtype="0" fill="hold" grpId="0" nodeType="withEffect">
-                                  <p:stCondLst>
-                                    <p:cond delay="0"/>
-                                  </p:stCondLst>
-                                  <p:childTnLst>
-                                    <p:set>
-                                      <p:cBhvr>
-                                        <p:cTn id="34" dur="1" fill="hold">
-                                          <p:stCondLst>
-                                            <p:cond delay="0"/>
-                                          </p:stCondLst>
-                                        </p:cTn>
-                                        <p:tgtEl>
-                                          <p:spTgt spid="3">
-                                            <p:txEl>
-                                              <p:pRg st="10" end="10"/>
-                                            </p:txEl>
-                                          </p:spTgt>
-                                        </p:tgtEl>
-                                        <p:attrNameLst>
-                                          <p:attrName>style.visibility</p:attrName>
-                                        </p:attrNameLst>
-                                      </p:cBhvr>
-                                      <p:to>
-                                        <p:strVal val="visible"/>
-                                      </p:to>
-                                    </p:set>
-                                  </p:childTnLst>
-                                </p:cTn>
-                              </p:par>
-                            </p:childTnLst>
-                          </p:cTn>
-                        </p:par>
-                      </p:childTnLst>
-                    </p:cTn>
-                  </p:par>
-                </p:childTnLst>
-              </p:cTn>
-              <p:prevCondLst>
-                <p:cond evt="onPrev" delay="0">
-                  <p:tgtEl>
-                    <p:sldTgt/>
-                  </p:tgtEl>
-                </p:cond>
-              </p:prevCondLst>
-              <p:nextCondLst>
-                <p:cond evt="onNext" delay="0">
-                  <p:tgtEl>
-                    <p:sldTgt/>
-                  </p:tgtEl>
-                </p:cond>
-              </p:nextCondLst>
-            </p:seq>
-          </p:childTnLst>
-        </p:cTn>
-      </p:par>
-    </p:tnLst>
-    <p:bldLst>
-      <p:bldP spid="3" grpId="0" build="p"/>
-    </p:bldLst>
-  </p:timing>
-</p:sld>
-</file>
-
-<file path=ppt/slides/slide2.xml><?xml version="1.0" encoding="utf-8"?>
-<p:sld xmlns:a="http://schemas.openxmlformats.org/drawingml/2006/main" xmlns:r="http://schemas.openxmlformats.org/officeDocument/2006/relationships" xmlns:p="http://schemas.openxmlformats.org/presentationml/2006/main">
-  <p:cSld>
-    <p:spTree>
-      <p:nvGrpSpPr>
-        <p:cNvPr id="1" name=""/>
-        <p:cNvGrpSpPr/>
-        <p:nvPr/>
-      </p:nvGrpSpPr>
-      <p:grpSpPr>
-        <a:xfrm>
-          <a:off x="0" y="0"/>
-          <a:ext cx="0" cy="0"/>
-          <a:chOff x="0" y="0"/>
-          <a:chExt cx="0" cy="0"/>
-        </a:xfrm>
-      </p:grpSpPr>
-      <p:sp>
-        <p:nvSpPr>
-          <p:cNvPr id="2" name="Titolo 1">
-            <a:extLst>
-              <a:ext uri="{FF2B5EF4-FFF2-40B4-BE49-F238E27FC236}">
-                <a16:creationId xmlns:a16="http://schemas.microsoft.com/office/drawing/2014/main" id="{0AAE64F4-E439-3CF6-991A-5B1723033A82}"/>
-              </a:ext>
-            </a:extLst>
-          </p:cNvPr>
-          <p:cNvSpPr>
-            <a:spLocks noGrp="1"/>
-          </p:cNvSpPr>
-          <p:nvPr>
-            <p:ph type="title"/>
-          </p:nvPr>
-        </p:nvSpPr>
-        <p:spPr/>
-        <p:txBody>
-          <a:bodyPr/>
-          <a:lstStyle/>
-          <a:p>
-            <a:r>
-              <a:rPr lang="pt-BR" dirty="0"/>
-              <a:t>What is this course about?</a:t>
-            </a:r>
-            <a:endParaRPr lang="it-IT" dirty="0"/>
-          </a:p>
-        </p:txBody>
-      </p:sp>
-      <p:sp>
-        <p:nvSpPr>
-          <p:cNvPr id="3" name="Segnaposto contenuto 2">
-            <a:extLst>
-              <a:ext uri="{FF2B5EF4-FFF2-40B4-BE49-F238E27FC236}">
-                <a16:creationId xmlns:a16="http://schemas.microsoft.com/office/drawing/2014/main" id="{9F7E3C7E-ED33-BB6E-A497-4FD98281931C}"/>
-              </a:ext>
-            </a:extLst>
-          </p:cNvPr>
-          <p:cNvSpPr>
-            <a:spLocks noGrp="1"/>
-          </p:cNvSpPr>
-          <p:nvPr>
-            <p:ph idx="1"/>
-          </p:nvPr>
-        </p:nvSpPr>
-        <p:spPr>
-          <a:xfrm>
-            <a:off x="838201" y="1825625"/>
-            <a:ext cx="5257800" cy="4351338"/>
-          </a:xfrm>
-        </p:spPr>
-        <p:txBody>
-          <a:bodyPr>
-            <a:normAutofit/>
-          </a:bodyPr>
-          <a:lstStyle/>
-          <a:p>
-            <a:r>
-              <a:rPr lang="pt-BR" dirty="0"/>
-              <a:t>Natural language processing...with a twist.</a:t>
-            </a:r>
-          </a:p>
-        </p:txBody>
-      </p:sp>
-      <p:graphicFrame>
-        <p:nvGraphicFramePr>
-          <p:cNvPr id="4" name="Diagramma 3">
-            <a:extLst>
-              <a:ext uri="{FF2B5EF4-FFF2-40B4-BE49-F238E27FC236}">
-                <a16:creationId xmlns:a16="http://schemas.microsoft.com/office/drawing/2014/main" id="{688E9A27-F006-715F-D471-A307F8D4EBD3}"/>
-              </a:ext>
-            </a:extLst>
-          </p:cNvPr>
-          <p:cNvGraphicFramePr/>
-          <p:nvPr>
-            <p:extLst>
-              <p:ext uri="{D42A27DB-BD31-4B8C-83A1-F6EECF244321}">
-                <p14:modId xmlns:p14="http://schemas.microsoft.com/office/powerpoint/2010/main" val="695976813"/>
-              </p:ext>
-            </p:extLst>
-          </p:nvPr>
-        </p:nvGraphicFramePr>
-        <p:xfrm>
-          <a:off x="5084957" y="1690688"/>
-          <a:ext cx="7107044" cy="4587449"/>
-        </p:xfrm>
-        <a:graphic>
-          <a:graphicData uri="http://schemas.openxmlformats.org/drawingml/2006/diagram">
-            <dgm:relIds xmlns:dgm="http://schemas.openxmlformats.org/drawingml/2006/diagram" xmlns:r="http://schemas.openxmlformats.org/officeDocument/2006/relationships" r:dm="rId3" r:lo="rId4" r:qs="rId5" r:cs="rId6"/>
-          </a:graphicData>
-        </a:graphic>
-      </p:graphicFrame>
-      <p:sp>
-        <p:nvSpPr>
-          <p:cNvPr id="5" name="CasellaDiTesto 4">
-            <a:extLst>
-              <a:ext uri="{FF2B5EF4-FFF2-40B4-BE49-F238E27FC236}">
-                <a16:creationId xmlns:a16="http://schemas.microsoft.com/office/drawing/2014/main" id="{B54087F6-EC79-CBD0-EB6C-42A6237A85BE}"/>
-              </a:ext>
-            </a:extLst>
-          </p:cNvPr>
-          <p:cNvSpPr txBox="1"/>
-          <p:nvPr/>
-        </p:nvSpPr>
-        <p:spPr>
-          <a:xfrm>
-            <a:off x="7704166" y="3713357"/>
-            <a:ext cx="1004937" cy="369332"/>
-          </a:xfrm>
-          <a:prstGeom prst="rect">
-            <a:avLst/>
-          </a:prstGeom>
-          <a:noFill/>
-        </p:spPr>
-        <p:txBody>
-          <a:bodyPr wrap="square" rtlCol="0">
-            <a:spAutoFit/>
-          </a:bodyPr>
-          <a:lstStyle/>
-          <a:p>
-            <a:r>
-              <a:rPr lang="pt-BR" dirty="0"/>
-              <a:t>CSS</a:t>
-            </a:r>
-            <a:endParaRPr lang="it-IT" dirty="0"/>
-          </a:p>
-        </p:txBody>
-      </p:sp>
-      <p:sp>
-        <p:nvSpPr>
-          <p:cNvPr id="6" name="CasellaDiTesto 5">
-            <a:extLst>
-              <a:ext uri="{FF2B5EF4-FFF2-40B4-BE49-F238E27FC236}">
-                <a16:creationId xmlns:a16="http://schemas.microsoft.com/office/drawing/2014/main" id="{D81BC7AE-D5A2-43CE-E376-9FE4D801CA82}"/>
-              </a:ext>
-            </a:extLst>
-          </p:cNvPr>
-          <p:cNvSpPr txBox="1"/>
-          <p:nvPr/>
-        </p:nvSpPr>
-        <p:spPr>
-          <a:xfrm>
-            <a:off x="8943146" y="3713357"/>
-            <a:ext cx="1004937" cy="369332"/>
-          </a:xfrm>
-          <a:prstGeom prst="rect">
-            <a:avLst/>
-          </a:prstGeom>
-          <a:noFill/>
-        </p:spPr>
-        <p:txBody>
-          <a:bodyPr wrap="square" rtlCol="0">
-            <a:spAutoFit/>
-          </a:bodyPr>
-          <a:lstStyle/>
-          <a:p>
-            <a:r>
-              <a:rPr lang="pt-BR" dirty="0"/>
-              <a:t>NLP</a:t>
-            </a:r>
-            <a:endParaRPr lang="it-IT" dirty="0"/>
-          </a:p>
-        </p:txBody>
-      </p:sp>
-      <p:sp>
-        <p:nvSpPr>
-          <p:cNvPr id="7" name="CasellaDiTesto 6">
-            <a:extLst>
-              <a:ext uri="{FF2B5EF4-FFF2-40B4-BE49-F238E27FC236}">
-                <a16:creationId xmlns:a16="http://schemas.microsoft.com/office/drawing/2014/main" id="{6BD1A03E-6371-5EB9-EED3-EC6539A57B95}"/>
-              </a:ext>
-            </a:extLst>
-          </p:cNvPr>
-          <p:cNvSpPr txBox="1"/>
-          <p:nvPr/>
-        </p:nvSpPr>
-        <p:spPr>
-          <a:xfrm>
-            <a:off x="8440677" y="4626415"/>
-            <a:ext cx="1004937" cy="369332"/>
-          </a:xfrm>
-          <a:prstGeom prst="rect">
-            <a:avLst/>
-          </a:prstGeom>
-          <a:noFill/>
-        </p:spPr>
-        <p:txBody>
-          <a:bodyPr wrap="square" rtlCol="0">
-            <a:spAutoFit/>
-          </a:bodyPr>
-          <a:lstStyle/>
-          <a:p>
-            <a:r>
-              <a:rPr lang="pt-BR" dirty="0"/>
-              <a:t>PL</a:t>
-            </a:r>
-            <a:endParaRPr lang="it-IT" dirty="0"/>
-          </a:p>
-        </p:txBody>
-      </p:sp>
-      <p:cxnSp>
-        <p:nvCxnSpPr>
-          <p:cNvPr id="9" name="Connettore 2 8">
-            <a:extLst>
-              <a:ext uri="{FF2B5EF4-FFF2-40B4-BE49-F238E27FC236}">
-                <a16:creationId xmlns:a16="http://schemas.microsoft.com/office/drawing/2014/main" id="{35C3DAFA-05E9-5612-062B-0A3942A13BD1}"/>
-              </a:ext>
-            </a:extLst>
-          </p:cNvPr>
-          <p:cNvCxnSpPr>
-            <a:cxnSpLocks/>
-          </p:cNvCxnSpPr>
-          <p:nvPr/>
-        </p:nvCxnSpPr>
-        <p:spPr>
-          <a:xfrm flipH="1">
-            <a:off x="8638479" y="3546088"/>
-            <a:ext cx="2412380" cy="710226"/>
-          </a:xfrm>
-          <a:prstGeom prst="straightConnector1">
-            <a:avLst/>
-          </a:prstGeom>
-          <a:ln>
-            <a:tailEnd type="triangle"/>
-          </a:ln>
-        </p:spPr>
-        <p:style>
-          <a:lnRef idx="2">
-            <a:schemeClr val="accent1"/>
-          </a:lnRef>
-          <a:fillRef idx="0">
-            <a:schemeClr val="accent1"/>
-          </a:fillRef>
-          <a:effectRef idx="1">
-            <a:schemeClr val="accent1"/>
-          </a:effectRef>
-          <a:fontRef idx="minor">
-            <a:schemeClr val="tx1"/>
-          </a:fontRef>
-        </p:style>
-      </p:cxnSp>
-      <p:sp>
-        <p:nvSpPr>
-          <p:cNvPr id="10" name="CasellaDiTesto 9">
-            <a:extLst>
-              <a:ext uri="{FF2B5EF4-FFF2-40B4-BE49-F238E27FC236}">
-                <a16:creationId xmlns:a16="http://schemas.microsoft.com/office/drawing/2014/main" id="{1D4C44BE-71E2-5360-2EE2-DB54EFF94F04}"/>
-              </a:ext>
-            </a:extLst>
-          </p:cNvPr>
-          <p:cNvSpPr txBox="1"/>
-          <p:nvPr/>
-        </p:nvSpPr>
-        <p:spPr>
-          <a:xfrm>
-            <a:off x="10446039" y="3127246"/>
-            <a:ext cx="1588782" cy="369332"/>
-          </a:xfrm>
-          <a:prstGeom prst="rect">
-            <a:avLst/>
-          </a:prstGeom>
-          <a:noFill/>
-        </p:spPr>
-        <p:txBody>
-          <a:bodyPr wrap="square" rtlCol="0">
-            <a:spAutoFit/>
-          </a:bodyPr>
-          <a:lstStyle/>
-          <a:p>
-            <a:r>
-              <a:rPr lang="pt-BR" dirty="0"/>
-              <a:t>We are here</a:t>
-            </a:r>
-            <a:endParaRPr lang="it-IT" dirty="0"/>
-          </a:p>
-        </p:txBody>
-      </p:sp>
-    </p:spTree>
-    <p:extLst>
-      <p:ext uri="{BB962C8B-B14F-4D97-AF65-F5344CB8AC3E}">
-        <p14:creationId xmlns:p14="http://schemas.microsoft.com/office/powerpoint/2010/main" val="2915382756"/>
-      </p:ext>
-    </p:extLst>
-  </p:cSld>
-  <p:clrMapOvr>
-    <a:masterClrMapping/>
-  </p:clrMapOvr>
-  <p:timing>
-    <p:tnLst>
-      <p:par>
-        <p:cTn id="1" dur="indefinite" restart="never" nodeType="tmRoot">
-          <p:childTnLst>
-            <p:seq concurrent="1" nextAc="seek">
-              <p:cTn id="2" dur="indefinite" nodeType="mainSeq">
-                <p:childTnLst>
-                  <p:par>
-                    <p:cTn id="3" fill="hold">
-                      <p:stCondLst>
-                        <p:cond delay="indefinite"/>
-                      </p:stCondLst>
-                      <p:childTnLst>
-                        <p:par>
-                          <p:cTn id="4" fill="hold">
-                            <p:stCondLst>
-                              <p:cond delay="0"/>
-                            </p:stCondLst>
-                            <p:childTnLst>
-                              <p:par>
-                                <p:cTn id="5" presetID="1" presetClass="entr" presetSubtype="0" fill="hold" grpId="0" nodeType="clickEffect">
-                                  <p:stCondLst>
-                                    <p:cond delay="0"/>
-                                  </p:stCondLst>
-                                  <p:childTnLst>
-                                    <p:set>
-                                      <p:cBhvr>
-                                        <p:cTn id="6" dur="1" fill="hold">
-                                          <p:stCondLst>
-                                            <p:cond delay="0"/>
-                                          </p:stCondLst>
-                                        </p:cTn>
-                                        <p:tgtEl>
-                                          <p:spTgt spid="3">
-                                            <p:txEl>
-                                              <p:pRg st="0" end="0"/>
-                                            </p:txEl>
-                                          </p:spTgt>
-                                        </p:tgtEl>
-                                        <p:attrNameLst>
-                                          <p:attrName>style.visibility</p:attrName>
-                                        </p:attrNameLst>
-                                      </p:cBhvr>
-                                      <p:to>
-                                        <p:strVal val="visible"/>
-                                      </p:to>
-                                    </p:set>
-                                  </p:childTnLst>
-                                </p:cTn>
-                              </p:par>
-                            </p:childTnLst>
-                          </p:cTn>
-                        </p:par>
-                      </p:childTnLst>
-                    </p:cTn>
-                  </p:par>
-                  <p:par>
-                    <p:cTn id="7" fill="hold">
-                      <p:stCondLst>
-                        <p:cond delay="indefinite"/>
-                      </p:stCondLst>
-                      <p:childTnLst>
-                        <p:par>
-                          <p:cTn id="8" fill="hold">
-                            <p:stCondLst>
-                              <p:cond delay="0"/>
-                            </p:stCondLst>
-                            <p:childTnLst>
-                              <p:par>
-                                <p:cTn id="9" presetID="1" presetClass="entr" presetSubtype="0" fill="hold" grpId="0" nodeType="clickEffect">
-                                  <p:stCondLst>
-                                    <p:cond delay="0"/>
-                                  </p:stCondLst>
-                                  <p:childTnLst>
-                                    <p:set>
-                                      <p:cBhvr>
-                                        <p:cTn id="10" dur="1" fill="hold">
-                                          <p:stCondLst>
-                                            <p:cond delay="0"/>
-                                          </p:stCondLst>
-                                        </p:cTn>
-                                        <p:tgtEl>
-                                          <p:spTgt spid="4"/>
-                                        </p:tgtEl>
-                                        <p:attrNameLst>
-                                          <p:attrName>style.visibility</p:attrName>
-                                        </p:attrNameLst>
-                                      </p:cBhvr>
-                                      <p:to>
-                                        <p:strVal val="visible"/>
-                                      </p:to>
-                                    </p:set>
-                                  </p:childTnLst>
-                                </p:cTn>
-                              </p:par>
-                            </p:childTnLst>
-                          </p:cTn>
-                        </p:par>
-                      </p:childTnLst>
-                    </p:cTn>
-                  </p:par>
-                  <p:par>
-                    <p:cTn id="11" fill="hold">
-                      <p:stCondLst>
-                        <p:cond delay="indefinite"/>
-                      </p:stCondLst>
-                      <p:childTnLst>
-                        <p:par>
-                          <p:cTn id="12" fill="hold">
-                            <p:stCondLst>
-                              <p:cond delay="0"/>
-                            </p:stCondLst>
-                            <p:childTnLst>
-                              <p:par>
-                                <p:cTn id="13" presetID="1" presetClass="entr" presetSubtype="0" fill="hold" grpId="0" nodeType="clickEffect">
-                                  <p:stCondLst>
-                                    <p:cond delay="0"/>
-                                  </p:stCondLst>
-                                  <p:childTnLst>
-                                    <p:set>
-                                      <p:cBhvr>
-                                        <p:cTn id="14" dur="1" fill="hold">
-                                          <p:stCondLst>
-                                            <p:cond delay="0"/>
-                                          </p:stCondLst>
-                                        </p:cTn>
-                                        <p:tgtEl>
-                                          <p:spTgt spid="6"/>
-                                        </p:tgtEl>
-                                        <p:attrNameLst>
-                                          <p:attrName>style.visibility</p:attrName>
-                                        </p:attrNameLst>
-                                      </p:cBhvr>
-                                      <p:to>
-                                        <p:strVal val="visible"/>
-                                      </p:to>
-                                    </p:set>
-                                  </p:childTnLst>
-                                </p:cTn>
-                              </p:par>
-                              <p:par>
-                                <p:cTn id="15" presetID="1" presetClass="entr" presetSubtype="0" fill="hold" grpId="0" nodeType="withEffect">
-                                  <p:stCondLst>
-                                    <p:cond delay="0"/>
-                                  </p:stCondLst>
-                                  <p:childTnLst>
-                                    <p:set>
-                                      <p:cBhvr>
-                                        <p:cTn id="16" dur="1" fill="hold">
-                                          <p:stCondLst>
-                                            <p:cond delay="0"/>
-                                          </p:stCondLst>
-                                        </p:cTn>
-                                        <p:tgtEl>
-                                          <p:spTgt spid="5"/>
-                                        </p:tgtEl>
-                                        <p:attrNameLst>
-                                          <p:attrName>style.visibility</p:attrName>
-                                        </p:attrNameLst>
-                                      </p:cBhvr>
-                                      <p:to>
-                                        <p:strVal val="visible"/>
-                                      </p:to>
-                                    </p:set>
-                                  </p:childTnLst>
-                                </p:cTn>
-                              </p:par>
-                              <p:par>
-                                <p:cTn id="17" presetID="1" presetClass="entr" presetSubtype="0" fill="hold" grpId="0" nodeType="withEffect">
-                                  <p:stCondLst>
-                                    <p:cond delay="0"/>
-                                  </p:stCondLst>
-                                  <p:childTnLst>
-                                    <p:set>
-                                      <p:cBhvr>
-                                        <p:cTn id="18" dur="1" fill="hold">
-                                          <p:stCondLst>
-                                            <p:cond delay="0"/>
-                                          </p:stCondLst>
-                                        </p:cTn>
-                                        <p:tgtEl>
-                                          <p:spTgt spid="7"/>
-                                        </p:tgtEl>
-                                        <p:attrNameLst>
-                                          <p:attrName>style.visibility</p:attrName>
-                                        </p:attrNameLst>
-                                      </p:cBhvr>
-                                      <p:to>
-                                        <p:strVal val="visible"/>
-                                      </p:to>
-                                    </p:set>
-                                  </p:childTnLst>
-                                </p:cTn>
-                              </p:par>
-                            </p:childTnLst>
-                          </p:cTn>
-                        </p:par>
-                      </p:childTnLst>
-                    </p:cTn>
-                  </p:par>
-                  <p:par>
-                    <p:cTn id="19" fill="hold">
-                      <p:stCondLst>
-                        <p:cond delay="indefinite"/>
-                      </p:stCondLst>
-                      <p:childTnLst>
-                        <p:par>
-                          <p:cTn id="20" fill="hold">
-                            <p:stCondLst>
-                              <p:cond delay="0"/>
-                            </p:stCondLst>
-                            <p:childTnLst>
-                              <p:par>
-                                <p:cTn id="21" presetID="1" presetClass="entr" presetSubtype="0" fill="hold" grpId="0" nodeType="clickEffect">
-                                  <p:stCondLst>
-                                    <p:cond delay="0"/>
-                                  </p:stCondLst>
-                                  <p:childTnLst>
-                                    <p:set>
-                                      <p:cBhvr>
-                                        <p:cTn id="22" dur="1" fill="hold">
-                                          <p:stCondLst>
-                                            <p:cond delay="0"/>
-                                          </p:stCondLst>
-                                        </p:cTn>
-                                        <p:tgtEl>
-                                          <p:spTgt spid="10"/>
-                                        </p:tgtEl>
-                                        <p:attrNameLst>
-                                          <p:attrName>style.visibility</p:attrName>
-                                        </p:attrNameLst>
-                                      </p:cBhvr>
-                                      <p:to>
-                                        <p:strVal val="visible"/>
-                                      </p:to>
-                                    </p:set>
-                                  </p:childTnLst>
-                                </p:cTn>
-                              </p:par>
-                              <p:par>
-                                <p:cTn id="23" presetID="1" presetClass="entr" presetSubtype="0" fill="hold" nodeType="withEffect">
-                                  <p:stCondLst>
-                                    <p:cond delay="0"/>
-                                  </p:stCondLst>
-                                  <p:childTnLst>
-                                    <p:set>
-                                      <p:cBhvr>
-                                        <p:cTn id="24" dur="1" fill="hold">
-                                          <p:stCondLst>
-                                            <p:cond delay="0"/>
-                                          </p:stCondLst>
-                                        </p:cTn>
-                                        <p:tgtEl>
-                                          <p:spTgt spid="9"/>
-                                        </p:tgtEl>
-                                        <p:attrNameLst>
-                                          <p:attrName>style.visibility</p:attrName>
-                                        </p:attrNameLst>
-                                      </p:cBhvr>
-                                      <p:to>
-                                        <p:strVal val="visible"/>
-                                      </p:to>
-                                    </p:set>
-                                  </p:childTnLst>
-                                </p:cTn>
-                              </p:par>
-                            </p:childTnLst>
-                          </p:cTn>
-                        </p:par>
-                      </p:childTnLst>
-                    </p:cTn>
-                  </p:par>
-                </p:childTnLst>
-              </p:cTn>
-              <p:prevCondLst>
-                <p:cond evt="onPrev" delay="0">
-                  <p:tgtEl>
-                    <p:sldTgt/>
-                  </p:tgtEl>
-                </p:cond>
-              </p:prevCondLst>
-              <p:nextCondLst>
-                <p:cond evt="onNext" delay="0">
-                  <p:tgtEl>
-                    <p:sldTgt/>
-                  </p:tgtEl>
-                </p:cond>
-              </p:nextCondLst>
-            </p:seq>
-          </p:childTnLst>
-        </p:cTn>
-      </p:par>
-    </p:tnLst>
-    <p:bldLst>
-      <p:bldP spid="3" grpId="0" uiExpand="1" build="p"/>
-      <p:bldGraphic spid="4" grpId="0">
-        <p:bldAsOne/>
-      </p:bldGraphic>
-      <p:bldP spid="5" grpId="0"/>
-      <p:bldP spid="6" grpId="0"/>
-      <p:bldP spid="7" grpId="0"/>
-      <p:bldP spid="10" grpId="0"/>
-    </p:bldLst>
-  </p:timing>
-</p:sld>
-</file>
-
-<file path=ppt/slides/slide20.xml><?xml version="1.0" encoding="utf-8"?>
+<file path=ppt/slides/slide18.xml><?xml version="1.0" encoding="utf-8"?>
 <p:sld xmlns:a="http://schemas.openxmlformats.org/drawingml/2006/main" xmlns:r="http://schemas.openxmlformats.org/officeDocument/2006/relationships" xmlns:p="http://schemas.openxmlformats.org/presentationml/2006/main">
   <p:cSld>
     <p:spTree>
@@ -21913,7 +19349,7 @@
 </p:sld>
 </file>
 
-<file path=ppt/slides/slide21.xml><?xml version="1.0" encoding="utf-8"?>
+<file path=ppt/slides/slide19.xml><?xml version="1.0" encoding="utf-8"?>
 <p:sld xmlns:a="http://schemas.openxmlformats.org/drawingml/2006/main" xmlns:r="http://schemas.openxmlformats.org/officeDocument/2006/relationships" xmlns:p="http://schemas.openxmlformats.org/presentationml/2006/main">
   <p:cSld>
     <p:spTree>
@@ -22312,7 +19748,619 @@
 </p:sld>
 </file>
 
-<file path=ppt/slides/slide22.xml><?xml version="1.0" encoding="utf-8"?>
+<file path=ppt/slides/slide2.xml><?xml version="1.0" encoding="utf-8"?>
+<p:sld xmlns:a="http://schemas.openxmlformats.org/drawingml/2006/main" xmlns:r="http://schemas.openxmlformats.org/officeDocument/2006/relationships" xmlns:p="http://schemas.openxmlformats.org/presentationml/2006/main">
+  <p:cSld>
+    <p:spTree>
+      <p:nvGrpSpPr>
+        <p:cNvPr id="1" name=""/>
+        <p:cNvGrpSpPr/>
+        <p:nvPr/>
+      </p:nvGrpSpPr>
+      <p:grpSpPr>
+        <a:xfrm>
+          <a:off x="0" y="0"/>
+          <a:ext cx="0" cy="0"/>
+          <a:chOff x="0" y="0"/>
+          <a:chExt cx="0" cy="0"/>
+        </a:xfrm>
+      </p:grpSpPr>
+      <p:sp>
+        <p:nvSpPr>
+          <p:cNvPr id="2" name="Titolo 1">
+            <a:extLst>
+              <a:ext uri="{FF2B5EF4-FFF2-40B4-BE49-F238E27FC236}">
+                <a16:creationId xmlns:a16="http://schemas.microsoft.com/office/drawing/2014/main" id="{0AAE64F4-E439-3CF6-991A-5B1723033A82}"/>
+              </a:ext>
+            </a:extLst>
+          </p:cNvPr>
+          <p:cNvSpPr>
+            <a:spLocks noGrp="1"/>
+          </p:cNvSpPr>
+          <p:nvPr>
+            <p:ph type="title"/>
+          </p:nvPr>
+        </p:nvSpPr>
+        <p:spPr/>
+        <p:txBody>
+          <a:bodyPr/>
+          <a:lstStyle/>
+          <a:p>
+            <a:r>
+              <a:rPr lang="pt-BR" dirty="0"/>
+              <a:t>What is this course about?</a:t>
+            </a:r>
+            <a:endParaRPr lang="it-IT" dirty="0"/>
+          </a:p>
+        </p:txBody>
+      </p:sp>
+      <p:sp>
+        <p:nvSpPr>
+          <p:cNvPr id="3" name="Segnaposto contenuto 2">
+            <a:extLst>
+              <a:ext uri="{FF2B5EF4-FFF2-40B4-BE49-F238E27FC236}">
+                <a16:creationId xmlns:a16="http://schemas.microsoft.com/office/drawing/2014/main" id="{9F7E3C7E-ED33-BB6E-A497-4FD98281931C}"/>
+              </a:ext>
+            </a:extLst>
+          </p:cNvPr>
+          <p:cNvSpPr>
+            <a:spLocks noGrp="1"/>
+          </p:cNvSpPr>
+          <p:nvPr>
+            <p:ph idx="1"/>
+          </p:nvPr>
+        </p:nvSpPr>
+        <p:spPr>
+          <a:xfrm>
+            <a:off x="838201" y="1825625"/>
+            <a:ext cx="5257800" cy="4351338"/>
+          </a:xfrm>
+        </p:spPr>
+        <p:txBody>
+          <a:bodyPr>
+            <a:normAutofit/>
+          </a:bodyPr>
+          <a:lstStyle/>
+          <a:p>
+            <a:r>
+              <a:rPr lang="pt-BR" dirty="0"/>
+              <a:t>Natural language processing...with a twist.</a:t>
+            </a:r>
+          </a:p>
+        </p:txBody>
+      </p:sp>
+      <p:graphicFrame>
+        <p:nvGraphicFramePr>
+          <p:cNvPr id="4" name="Diagramma 3">
+            <a:extLst>
+              <a:ext uri="{FF2B5EF4-FFF2-40B4-BE49-F238E27FC236}">
+                <a16:creationId xmlns:a16="http://schemas.microsoft.com/office/drawing/2014/main" id="{688E9A27-F006-715F-D471-A307F8D4EBD3}"/>
+              </a:ext>
+            </a:extLst>
+          </p:cNvPr>
+          <p:cNvGraphicFramePr/>
+          <p:nvPr>
+            <p:extLst>
+              <p:ext uri="{D42A27DB-BD31-4B8C-83A1-F6EECF244321}">
+                <p14:modId xmlns:p14="http://schemas.microsoft.com/office/powerpoint/2010/main" val="695976813"/>
+              </p:ext>
+            </p:extLst>
+          </p:nvPr>
+        </p:nvGraphicFramePr>
+        <p:xfrm>
+          <a:off x="5084957" y="1690688"/>
+          <a:ext cx="7107044" cy="4587449"/>
+        </p:xfrm>
+        <a:graphic>
+          <a:graphicData uri="http://schemas.openxmlformats.org/drawingml/2006/diagram">
+            <dgm:relIds xmlns:dgm="http://schemas.openxmlformats.org/drawingml/2006/diagram" xmlns:r="http://schemas.openxmlformats.org/officeDocument/2006/relationships" r:dm="rId3" r:lo="rId4" r:qs="rId5" r:cs="rId6"/>
+          </a:graphicData>
+        </a:graphic>
+      </p:graphicFrame>
+      <p:sp>
+        <p:nvSpPr>
+          <p:cNvPr id="5" name="CasellaDiTesto 4">
+            <a:extLst>
+              <a:ext uri="{FF2B5EF4-FFF2-40B4-BE49-F238E27FC236}">
+                <a16:creationId xmlns:a16="http://schemas.microsoft.com/office/drawing/2014/main" id="{B54087F6-EC79-CBD0-EB6C-42A6237A85BE}"/>
+              </a:ext>
+            </a:extLst>
+          </p:cNvPr>
+          <p:cNvSpPr txBox="1"/>
+          <p:nvPr/>
+        </p:nvSpPr>
+        <p:spPr>
+          <a:xfrm>
+            <a:off x="7704166" y="3713357"/>
+            <a:ext cx="1004937" cy="369332"/>
+          </a:xfrm>
+          <a:prstGeom prst="rect">
+            <a:avLst/>
+          </a:prstGeom>
+          <a:noFill/>
+        </p:spPr>
+        <p:txBody>
+          <a:bodyPr wrap="square" rtlCol="0">
+            <a:spAutoFit/>
+          </a:bodyPr>
+          <a:lstStyle/>
+          <a:p>
+            <a:r>
+              <a:rPr lang="pt-BR" dirty="0"/>
+              <a:t>CSS</a:t>
+            </a:r>
+            <a:endParaRPr lang="it-IT" dirty="0"/>
+          </a:p>
+        </p:txBody>
+      </p:sp>
+      <p:sp>
+        <p:nvSpPr>
+          <p:cNvPr id="6" name="CasellaDiTesto 5">
+            <a:extLst>
+              <a:ext uri="{FF2B5EF4-FFF2-40B4-BE49-F238E27FC236}">
+                <a16:creationId xmlns:a16="http://schemas.microsoft.com/office/drawing/2014/main" id="{D81BC7AE-D5A2-43CE-E376-9FE4D801CA82}"/>
+              </a:ext>
+            </a:extLst>
+          </p:cNvPr>
+          <p:cNvSpPr txBox="1"/>
+          <p:nvPr/>
+        </p:nvSpPr>
+        <p:spPr>
+          <a:xfrm>
+            <a:off x="8943146" y="3713357"/>
+            <a:ext cx="1004937" cy="369332"/>
+          </a:xfrm>
+          <a:prstGeom prst="rect">
+            <a:avLst/>
+          </a:prstGeom>
+          <a:noFill/>
+        </p:spPr>
+        <p:txBody>
+          <a:bodyPr wrap="square" rtlCol="0">
+            <a:spAutoFit/>
+          </a:bodyPr>
+          <a:lstStyle/>
+          <a:p>
+            <a:r>
+              <a:rPr lang="pt-BR" dirty="0"/>
+              <a:t>NLP</a:t>
+            </a:r>
+            <a:endParaRPr lang="it-IT" dirty="0"/>
+          </a:p>
+        </p:txBody>
+      </p:sp>
+      <p:sp>
+        <p:nvSpPr>
+          <p:cNvPr id="7" name="CasellaDiTesto 6">
+            <a:extLst>
+              <a:ext uri="{FF2B5EF4-FFF2-40B4-BE49-F238E27FC236}">
+                <a16:creationId xmlns:a16="http://schemas.microsoft.com/office/drawing/2014/main" id="{6BD1A03E-6371-5EB9-EED3-EC6539A57B95}"/>
+              </a:ext>
+            </a:extLst>
+          </p:cNvPr>
+          <p:cNvSpPr txBox="1"/>
+          <p:nvPr/>
+        </p:nvSpPr>
+        <p:spPr>
+          <a:xfrm>
+            <a:off x="8440677" y="4626415"/>
+            <a:ext cx="1004937" cy="369332"/>
+          </a:xfrm>
+          <a:prstGeom prst="rect">
+            <a:avLst/>
+          </a:prstGeom>
+          <a:noFill/>
+        </p:spPr>
+        <p:txBody>
+          <a:bodyPr wrap="square" rtlCol="0">
+            <a:spAutoFit/>
+          </a:bodyPr>
+          <a:lstStyle/>
+          <a:p>
+            <a:r>
+              <a:rPr lang="pt-BR" dirty="0"/>
+              <a:t>PL</a:t>
+            </a:r>
+            <a:endParaRPr lang="it-IT" dirty="0"/>
+          </a:p>
+        </p:txBody>
+      </p:sp>
+      <p:cxnSp>
+        <p:nvCxnSpPr>
+          <p:cNvPr id="9" name="Connettore 2 8">
+            <a:extLst>
+              <a:ext uri="{FF2B5EF4-FFF2-40B4-BE49-F238E27FC236}">
+                <a16:creationId xmlns:a16="http://schemas.microsoft.com/office/drawing/2014/main" id="{35C3DAFA-05E9-5612-062B-0A3942A13BD1}"/>
+              </a:ext>
+            </a:extLst>
+          </p:cNvPr>
+          <p:cNvCxnSpPr>
+            <a:cxnSpLocks/>
+          </p:cNvCxnSpPr>
+          <p:nvPr/>
+        </p:nvCxnSpPr>
+        <p:spPr>
+          <a:xfrm flipH="1">
+            <a:off x="8638479" y="3546088"/>
+            <a:ext cx="2412380" cy="710226"/>
+          </a:xfrm>
+          <a:prstGeom prst="straightConnector1">
+            <a:avLst/>
+          </a:prstGeom>
+          <a:ln>
+            <a:tailEnd type="triangle"/>
+          </a:ln>
+        </p:spPr>
+        <p:style>
+          <a:lnRef idx="2">
+            <a:schemeClr val="accent1"/>
+          </a:lnRef>
+          <a:fillRef idx="0">
+            <a:schemeClr val="accent1"/>
+          </a:fillRef>
+          <a:effectRef idx="1">
+            <a:schemeClr val="accent1"/>
+          </a:effectRef>
+          <a:fontRef idx="minor">
+            <a:schemeClr val="tx1"/>
+          </a:fontRef>
+        </p:style>
+      </p:cxnSp>
+      <p:sp>
+        <p:nvSpPr>
+          <p:cNvPr id="10" name="CasellaDiTesto 9">
+            <a:extLst>
+              <a:ext uri="{FF2B5EF4-FFF2-40B4-BE49-F238E27FC236}">
+                <a16:creationId xmlns:a16="http://schemas.microsoft.com/office/drawing/2014/main" id="{1D4C44BE-71E2-5360-2EE2-DB54EFF94F04}"/>
+              </a:ext>
+            </a:extLst>
+          </p:cNvPr>
+          <p:cNvSpPr txBox="1"/>
+          <p:nvPr/>
+        </p:nvSpPr>
+        <p:spPr>
+          <a:xfrm>
+            <a:off x="10446039" y="3127246"/>
+            <a:ext cx="1588782" cy="369332"/>
+          </a:xfrm>
+          <a:prstGeom prst="rect">
+            <a:avLst/>
+          </a:prstGeom>
+          <a:noFill/>
+        </p:spPr>
+        <p:txBody>
+          <a:bodyPr wrap="square" rtlCol="0">
+            <a:spAutoFit/>
+          </a:bodyPr>
+          <a:lstStyle/>
+          <a:p>
+            <a:r>
+              <a:rPr lang="pt-BR" dirty="0"/>
+              <a:t>We are here</a:t>
+            </a:r>
+            <a:endParaRPr lang="it-IT" dirty="0"/>
+          </a:p>
+        </p:txBody>
+      </p:sp>
+    </p:spTree>
+    <p:extLst>
+      <p:ext uri="{BB962C8B-B14F-4D97-AF65-F5344CB8AC3E}">
+        <p14:creationId xmlns:p14="http://schemas.microsoft.com/office/powerpoint/2010/main" val="2915382756"/>
+      </p:ext>
+    </p:extLst>
+  </p:cSld>
+  <p:clrMapOvr>
+    <a:masterClrMapping/>
+  </p:clrMapOvr>
+  <p:timing>
+    <p:tnLst>
+      <p:par>
+        <p:cTn id="1" dur="indefinite" restart="never" nodeType="tmRoot">
+          <p:childTnLst>
+            <p:seq concurrent="1" nextAc="seek">
+              <p:cTn id="2" dur="indefinite" nodeType="mainSeq">
+                <p:childTnLst>
+                  <p:par>
+                    <p:cTn id="3" fill="hold">
+                      <p:stCondLst>
+                        <p:cond delay="indefinite"/>
+                      </p:stCondLst>
+                      <p:childTnLst>
+                        <p:par>
+                          <p:cTn id="4" fill="hold">
+                            <p:stCondLst>
+                              <p:cond delay="0"/>
+                            </p:stCondLst>
+                            <p:childTnLst>
+                              <p:par>
+                                <p:cTn id="5" presetID="1" presetClass="entr" presetSubtype="0" fill="hold" grpId="0" nodeType="clickEffect">
+                                  <p:stCondLst>
+                                    <p:cond delay="0"/>
+                                  </p:stCondLst>
+                                  <p:childTnLst>
+                                    <p:set>
+                                      <p:cBhvr>
+                                        <p:cTn id="6" dur="1" fill="hold">
+                                          <p:stCondLst>
+                                            <p:cond delay="0"/>
+                                          </p:stCondLst>
+                                        </p:cTn>
+                                        <p:tgtEl>
+                                          <p:spTgt spid="3">
+                                            <p:txEl>
+                                              <p:pRg st="0" end="0"/>
+                                            </p:txEl>
+                                          </p:spTgt>
+                                        </p:tgtEl>
+                                        <p:attrNameLst>
+                                          <p:attrName>style.visibility</p:attrName>
+                                        </p:attrNameLst>
+                                      </p:cBhvr>
+                                      <p:to>
+                                        <p:strVal val="visible"/>
+                                      </p:to>
+                                    </p:set>
+                                  </p:childTnLst>
+                                </p:cTn>
+                              </p:par>
+                            </p:childTnLst>
+                          </p:cTn>
+                        </p:par>
+                      </p:childTnLst>
+                    </p:cTn>
+                  </p:par>
+                  <p:par>
+                    <p:cTn id="7" fill="hold">
+                      <p:stCondLst>
+                        <p:cond delay="indefinite"/>
+                      </p:stCondLst>
+                      <p:childTnLst>
+                        <p:par>
+                          <p:cTn id="8" fill="hold">
+                            <p:stCondLst>
+                              <p:cond delay="0"/>
+                            </p:stCondLst>
+                            <p:childTnLst>
+                              <p:par>
+                                <p:cTn id="9" presetID="1" presetClass="entr" presetSubtype="0" fill="hold" grpId="0" nodeType="clickEffect">
+                                  <p:stCondLst>
+                                    <p:cond delay="0"/>
+                                  </p:stCondLst>
+                                  <p:childTnLst>
+                                    <p:set>
+                                      <p:cBhvr>
+                                        <p:cTn id="10" dur="1" fill="hold">
+                                          <p:stCondLst>
+                                            <p:cond delay="0"/>
+                                          </p:stCondLst>
+                                        </p:cTn>
+                                        <p:tgtEl>
+                                          <p:spTgt spid="4"/>
+                                        </p:tgtEl>
+                                        <p:attrNameLst>
+                                          <p:attrName>style.visibility</p:attrName>
+                                        </p:attrNameLst>
+                                      </p:cBhvr>
+                                      <p:to>
+                                        <p:strVal val="visible"/>
+                                      </p:to>
+                                    </p:set>
+                                  </p:childTnLst>
+                                </p:cTn>
+                              </p:par>
+                            </p:childTnLst>
+                          </p:cTn>
+                        </p:par>
+                      </p:childTnLst>
+                    </p:cTn>
+                  </p:par>
+                  <p:par>
+                    <p:cTn id="11" fill="hold">
+                      <p:stCondLst>
+                        <p:cond delay="indefinite"/>
+                      </p:stCondLst>
+                      <p:childTnLst>
+                        <p:par>
+                          <p:cTn id="12" fill="hold">
+                            <p:stCondLst>
+                              <p:cond delay="0"/>
+                            </p:stCondLst>
+                            <p:childTnLst>
+                              <p:par>
+                                <p:cTn id="13" presetID="1" presetClass="entr" presetSubtype="0" fill="hold" grpId="0" nodeType="clickEffect">
+                                  <p:stCondLst>
+                                    <p:cond delay="0"/>
+                                  </p:stCondLst>
+                                  <p:childTnLst>
+                                    <p:set>
+                                      <p:cBhvr>
+                                        <p:cTn id="14" dur="1" fill="hold">
+                                          <p:stCondLst>
+                                            <p:cond delay="0"/>
+                                          </p:stCondLst>
+                                        </p:cTn>
+                                        <p:tgtEl>
+                                          <p:spTgt spid="6"/>
+                                        </p:tgtEl>
+                                        <p:attrNameLst>
+                                          <p:attrName>style.visibility</p:attrName>
+                                        </p:attrNameLst>
+                                      </p:cBhvr>
+                                      <p:to>
+                                        <p:strVal val="visible"/>
+                                      </p:to>
+                                    </p:set>
+                                  </p:childTnLst>
+                                </p:cTn>
+                              </p:par>
+                              <p:par>
+                                <p:cTn id="15" presetID="1" presetClass="entr" presetSubtype="0" fill="hold" grpId="0" nodeType="withEffect">
+                                  <p:stCondLst>
+                                    <p:cond delay="0"/>
+                                  </p:stCondLst>
+                                  <p:childTnLst>
+                                    <p:set>
+                                      <p:cBhvr>
+                                        <p:cTn id="16" dur="1" fill="hold">
+                                          <p:stCondLst>
+                                            <p:cond delay="0"/>
+                                          </p:stCondLst>
+                                        </p:cTn>
+                                        <p:tgtEl>
+                                          <p:spTgt spid="5"/>
+                                        </p:tgtEl>
+                                        <p:attrNameLst>
+                                          <p:attrName>style.visibility</p:attrName>
+                                        </p:attrNameLst>
+                                      </p:cBhvr>
+                                      <p:to>
+                                        <p:strVal val="visible"/>
+                                      </p:to>
+                                    </p:set>
+                                  </p:childTnLst>
+                                </p:cTn>
+                              </p:par>
+                              <p:par>
+                                <p:cTn id="17" presetID="1" presetClass="entr" presetSubtype="0" fill="hold" grpId="0" nodeType="withEffect">
+                                  <p:stCondLst>
+                                    <p:cond delay="0"/>
+                                  </p:stCondLst>
+                                  <p:childTnLst>
+                                    <p:set>
+                                      <p:cBhvr>
+                                        <p:cTn id="18" dur="1" fill="hold">
+                                          <p:stCondLst>
+                                            <p:cond delay="0"/>
+                                          </p:stCondLst>
+                                        </p:cTn>
+                                        <p:tgtEl>
+                                          <p:spTgt spid="7"/>
+                                        </p:tgtEl>
+                                        <p:attrNameLst>
+                                          <p:attrName>style.visibility</p:attrName>
+                                        </p:attrNameLst>
+                                      </p:cBhvr>
+                                      <p:to>
+                                        <p:strVal val="visible"/>
+                                      </p:to>
+                                    </p:set>
+                                  </p:childTnLst>
+                                </p:cTn>
+                              </p:par>
+                            </p:childTnLst>
+                          </p:cTn>
+                        </p:par>
+                      </p:childTnLst>
+                    </p:cTn>
+                  </p:par>
+                  <p:par>
+                    <p:cTn id="19" fill="hold">
+                      <p:stCondLst>
+                        <p:cond delay="indefinite"/>
+                      </p:stCondLst>
+                      <p:childTnLst>
+                        <p:par>
+                          <p:cTn id="20" fill="hold">
+                            <p:stCondLst>
+                              <p:cond delay="0"/>
+                            </p:stCondLst>
+                            <p:childTnLst>
+                              <p:par>
+                                <p:cTn id="21" presetID="1" presetClass="entr" presetSubtype="0" fill="hold" grpId="0" nodeType="clickEffect">
+                                  <p:stCondLst>
+                                    <p:cond delay="0"/>
+                                  </p:stCondLst>
+                                  <p:childTnLst>
+                                    <p:set>
+                                      <p:cBhvr>
+                                        <p:cTn id="22" dur="1" fill="hold">
+                                          <p:stCondLst>
+                                            <p:cond delay="0"/>
+                                          </p:stCondLst>
+                                        </p:cTn>
+                                        <p:tgtEl>
+                                          <p:spTgt spid="10"/>
+                                        </p:tgtEl>
+                                        <p:attrNameLst>
+                                          <p:attrName>style.visibility</p:attrName>
+                                        </p:attrNameLst>
+                                      </p:cBhvr>
+                                      <p:to>
+                                        <p:strVal val="visible"/>
+                                      </p:to>
+                                    </p:set>
+                                  </p:childTnLst>
+                                </p:cTn>
+                              </p:par>
+                              <p:par>
+                                <p:cTn id="23" presetID="1" presetClass="entr" presetSubtype="0" fill="hold" nodeType="withEffect">
+                                  <p:stCondLst>
+                                    <p:cond delay="0"/>
+                                  </p:stCondLst>
+                                  <p:childTnLst>
+                                    <p:set>
+                                      <p:cBhvr>
+                                        <p:cTn id="24" dur="1" fill="hold">
+                                          <p:stCondLst>
+                                            <p:cond delay="0"/>
+                                          </p:stCondLst>
+                                        </p:cTn>
+                                        <p:tgtEl>
+                                          <p:spTgt spid="9"/>
+                                        </p:tgtEl>
+                                        <p:attrNameLst>
+                                          <p:attrName>style.visibility</p:attrName>
+                                        </p:attrNameLst>
+                                      </p:cBhvr>
+                                      <p:to>
+                                        <p:strVal val="visible"/>
+                                      </p:to>
+                                    </p:set>
+                                  </p:childTnLst>
+                                </p:cTn>
+                              </p:par>
+                            </p:childTnLst>
+                          </p:cTn>
+                        </p:par>
+                      </p:childTnLst>
+                    </p:cTn>
+                  </p:par>
+                </p:childTnLst>
+              </p:cTn>
+              <p:prevCondLst>
+                <p:cond evt="onPrev" delay="0">
+                  <p:tgtEl>
+                    <p:sldTgt/>
+                  </p:tgtEl>
+                </p:cond>
+              </p:prevCondLst>
+              <p:nextCondLst>
+                <p:cond evt="onNext" delay="0">
+                  <p:tgtEl>
+                    <p:sldTgt/>
+                  </p:tgtEl>
+                </p:cond>
+              </p:nextCondLst>
+            </p:seq>
+          </p:childTnLst>
+        </p:cTn>
+      </p:par>
+    </p:tnLst>
+    <p:bldLst>
+      <p:bldP spid="3" grpId="0" uiExpand="1" build="p"/>
+      <p:bldGraphic spid="4" grpId="0">
+        <p:bldAsOne/>
+      </p:bldGraphic>
+      <p:bldP spid="5" grpId="0"/>
+      <p:bldP spid="6" grpId="0"/>
+      <p:bldP spid="7" grpId="0"/>
+      <p:bldP spid="10" grpId="0"/>
+    </p:bldLst>
+  </p:timing>
+</p:sld>
+</file>
+
+<file path=ppt/slides/slide20.xml><?xml version="1.0" encoding="utf-8"?>
 <p:sld xmlns:a="http://schemas.openxmlformats.org/drawingml/2006/main" xmlns:r="http://schemas.openxmlformats.org/officeDocument/2006/relationships" xmlns:p="http://schemas.openxmlformats.org/presentationml/2006/main">
   <p:cSld>
     <p:spTree>
@@ -22545,7 +20593,7 @@
 </p:sld>
 </file>
 
-<file path=ppt/slides/slide23.xml><?xml version="1.0" encoding="utf-8"?>
+<file path=ppt/slides/slide21.xml><?xml version="1.0" encoding="utf-8"?>
 <p:sld xmlns:a="http://schemas.openxmlformats.org/drawingml/2006/main" xmlns:r="http://schemas.openxmlformats.org/officeDocument/2006/relationships" xmlns:p="http://schemas.openxmlformats.org/presentationml/2006/main">
   <p:cSld>
     <p:spTree>
@@ -22729,7 +20777,7 @@
 </p:sld>
 </file>
 
-<file path=ppt/slides/slide24.xml><?xml version="1.0" encoding="utf-8"?>
+<file path=ppt/slides/slide22.xml><?xml version="1.0" encoding="utf-8"?>
 <p:sld xmlns:a="http://schemas.openxmlformats.org/drawingml/2006/main" xmlns:r="http://schemas.openxmlformats.org/officeDocument/2006/relationships" xmlns:p="http://schemas.openxmlformats.org/presentationml/2006/main">
   <p:cSld>
     <p:spTree>

</xml_diff>